<commit_message>
feat: unify Midnight Vault UI with archetype engine; refresh submissions for all 7 members
</commit_message>
<xml_diff>
--- a/submissions/CapExIQ_Executive_Presentation.pptx
+++ b/submissions/CapExIQ_Executive_Presentation.pptx
@@ -1742,7 +1742,7 @@
           <a:p>
             <a:r>
               <a:rPr lang="en-US" dirty="0"/>
-              <a:t>Question four. Ten capabilities, and every one is documented against the five points the brief asks for. The limitation column on the right is the one I care about. The finance assistant cannot be audited line by line, so its output is labelled advisory. The board recommendation will write a perfectly confident memorandum from bad inputs, which is why sign-off is mandatory rather than optional. And board debate — which simulates a CFO, COO, risk officer and a sceptical non-executive arguing the case — manufactures challenge a single author cannot supply, but simulated dissent is not real governance and I would not claim otherwise. (40s)</a:t>
+              <a:t>Question four. Twelve capabilities, each documented against the five points the brief asks for. Start at the top: the assistant now retrieves the relevant documentation before it answers, so every claim carries a numbered citation you can expand to the source extract. That turns an unverifiable answer into a checkable one. The limitation column on the right is the one I care about. The board recommendation will write a perfectly confident memorandum from bad inputs, which is why sign-off is mandatory. And board debate manufactures the challenge a single author cannot supply — but simulated dissent is not real governance, and I would not claim otherwise. (40s)</a:t>
             </a:r>
             <a:endParaRPr lang="en-US" dirty="0"/>
           </a:p>
@@ -1830,7 +1830,7 @@
           <a:p>
             <a:r>
               <a:rPr lang="en-US" dirty="0"/>
-              <a:t>The second five. Three worth calling out. Scenario studio proposes additional scenarios, but note the limitation: it proposes assumptions only, and the deterministic engine evaluates them. The AI never produces a result. ESG returns an explicit not-applicable flag for archetypes where the commentary would be meaningless, rather than inventing content to fill a section. And the quote parser returns ambiguous lines unparsed rather than guessing, because a wrong capex line silently entering the model is worse than a gap. The green box is the principle behind all of it: pull the API key out entirely and the financial results are byte-identical. (40s)</a:t>
+              <a:t>The second six. Three worth calling out. Scenario studio proposes assumptions only — the deterministic engine evaluates them; the AI never produces a result. ESG returns an explicit not-applicable flag where commentary would be meaningless, rather than inventing content to fill a section. And macro reference is the one with a story: it used to generate rates and publish them as live market data. It does not any more, and I will come back to that on the ethics slide. The green box is the principle behind all of it — pull the API key and the financial results are unchanged. (40s)</a:t>
             </a:r>
             <a:endParaRPr lang="en-US" dirty="0"/>
           </a:p>
@@ -1918,7 +1918,7 @@
           <a:p>
             <a:r>
               <a:rPr lang="en-US" dirty="0"/>
-              <a:t>The brief asks for seven things under ethical use of AI, and these are all seven. Two I would defend specifically. On accuracy — we did not write a policy saying AI should not calculate; we built it so it structurally cannot, because the routes only ever receive numbers already computed. On bias — forecasts inherit the optimism of whoever set them, and a model trained on published business cases amplifies that, so the pessimistic case and the simulated debate exist as deliberate counterweights. The box at the bottom matters most: responsibility sits with the CFO and the committee. Nothing here transfers accountability. (40s)</a:t>
+              <a:t>The brief asks for seven things under ethical use of AI, and these are all seven. But the amber box is the one I would actually defend the project on. An earlier build of our macro panel prompted the model to act as a real-time data ingestion agent and published what came back as observed market data. Nothing was ever fetched. Every interbank rate and tariff on that panel was generated, and it was being shown to a capital committee as fact. We found it, removed the generation step, and replaced it with hand-transcribed values carrying citations. That is the real lesson here: the danger is not that a model says something false, it is that a well-designed interface makes a generated figure look exactly like a measured one. Responsibility sits with the CFO and the committee. (50s)</a:t>
             </a:r>
             <a:endParaRPr lang="en-US" dirty="0"/>
           </a:p>
@@ -3825,8 +3825,8 @@
         </p:nvSpPr>
         <p:spPr>
           <a:xfrm>
-            <a:off x="566928" y="5989320"/>
-            <a:ext cx="11057839" cy="274320"/>
+            <a:off x="566928" y="5925312"/>
+            <a:ext cx="11057839" cy="256032"/>
           </a:xfrm>
           <a:prstGeom prst="rect">
             <a:avLst/>
@@ -3850,9 +3850,48 @@
                 <a:ea typeface="Calibri" pitchFamily="34" charset="-122"/>
                 <a:cs typeface="Calibri" pitchFamily="34" charset="-120"/>
               </a:rPr>
-              <a:t>Deterministic finance engine  ·  10 AI capabilities  ·  8 investment archetypes</a:t>
+              <a:t>Deterministic finance engine  ·  12 AI capabilities  ·  8 investment archetypes  ·  Role-based access control</a:t>
             </a:r>
             <a:endParaRPr lang="en-US" sz="1100" dirty="0"/>
+          </a:p>
+        </p:txBody>
+      </p:sp>
+      <p:sp>
+        <p:nvSpPr>
+          <p:cNvPr id="23" name="Text 21"/>
+          <p:cNvSpPr/>
+          <p:nvPr/>
+        </p:nvSpPr>
+        <p:spPr>
+          <a:xfrm>
+            <a:off x="566928" y="6217920"/>
+            <a:ext cx="11057839" cy="256032"/>
+          </a:xfrm>
+          <a:prstGeom prst="rect">
+            <a:avLst/>
+          </a:prstGeom>
+          <a:noFill/>
+          <a:ln/>
+        </p:spPr>
+        <p:txBody>
+          <a:bodyPr wrap="square" lIns="0" tIns="0" rIns="0" bIns="0" rtlCol="0" anchor="ctr"/>
+          <a:lstStyle/>
+          <a:p>
+            <a:pPr algn="ctr" indent="0" marL="0">
+              <a:buNone/>
+            </a:pPr>
+            <a:r>
+              <a:rPr lang="en-US" sz="1050" dirty="0">
+                <a:solidFill>
+                  <a:srgbClr val="CADCFC"/>
+                </a:solidFill>
+                <a:latin typeface="Calibri" pitchFamily="34" charset="0"/>
+                <a:ea typeface="Calibri" pitchFamily="34" charset="-122"/>
+                <a:cs typeface="Calibri" pitchFamily="34" charset="-120"/>
+              </a:rPr>
+              <a:t>Krishna Mathur  ·  Neel Kapadia  ·  Yash Petkar  ·  Atharva Soundankar  ·  Tanishk Verma  ·  Nihal Pusthe  ·  Karan Baid</a:t>
+            </a:r>
+            <a:endParaRPr lang="en-US" sz="1050" dirty="0"/>
           </a:p>
         </p:txBody>
       </p:sp>
@@ -6117,7 +6156,7 @@
                 <a:ea typeface="Cambria" pitchFamily="34" charset="-122"/>
                 <a:cs typeface="Cambria" pitchFamily="34" charset="-120"/>
               </a:rPr>
-              <a:t>Ten AI capabilities — the first five</a:t>
+              <a:t>Twelve AI capabilities — the first six</a:t>
             </a:r>
             <a:endParaRPr lang="en-US" sz="3000" dirty="0"/>
           </a:p>
@@ -6197,12 +6236,12 @@
         </p:nvSpPr>
         <p:spPr>
           <a:xfrm>
-            <a:off x="566928" y="1426464"/>
-            <a:ext cx="11057839" cy="768096"/>
+            <a:off x="566928" y="1335024"/>
+            <a:ext cx="11057839" cy="713232"/>
           </a:xfrm>
           <a:prstGeom prst="roundRect">
             <a:avLst>
-              <a:gd name="adj" fmla="val 11905"/>
+              <a:gd name="adj" fmla="val 12821"/>
             </a:avLst>
           </a:prstGeom>
           <a:solidFill>
@@ -6231,7 +6270,7 @@
         </p:nvSpPr>
         <p:spPr>
           <a:xfrm>
-            <a:off x="768096" y="1655064"/>
+            <a:off x="768096" y="1536192"/>
             <a:ext cx="310896" cy="310896"/>
           </a:xfrm>
           <a:prstGeom prst="ellipse">
@@ -6256,7 +6295,7 @@
         </p:nvSpPr>
         <p:spPr>
           <a:xfrm>
-            <a:off x="768096" y="1655064"/>
+            <a:off x="768096" y="1536192"/>
             <a:ext cx="310896" cy="310896"/>
           </a:xfrm>
           <a:prstGeom prst="rect">
@@ -6295,24 +6334,24 @@
         </p:nvSpPr>
         <p:spPr>
           <a:xfrm>
-            <a:off x="1188720" y="1481328"/>
-            <a:ext cx="2011680" cy="585216"/>
-          </a:xfrm>
-          <a:prstGeom prst="rect">
-            <a:avLst/>
-          </a:prstGeom>
-          <a:noFill/>
-          <a:ln/>
-        </p:spPr>
-        <p:txBody>
-          <a:bodyPr wrap="square" lIns="0" tIns="0" rIns="0" bIns="0" rtlCol="0" anchor="ctr"/>
-          <a:lstStyle/>
-          <a:p>
-            <a:pPr indent="0" marL="0">
-              <a:buNone/>
-            </a:pPr>
-            <a:r>
-              <a:rPr lang="en-US" sz="1200" b="1" dirty="0">
+            <a:off x="1188720" y="1389888"/>
+            <a:ext cx="2011680" cy="603504"/>
+          </a:xfrm>
+          <a:prstGeom prst="rect">
+            <a:avLst/>
+          </a:prstGeom>
+          <a:noFill/>
+          <a:ln/>
+        </p:spPr>
+        <p:txBody>
+          <a:bodyPr wrap="square" lIns="0" tIns="0" rIns="0" bIns="0" rtlCol="0" anchor="ctr"/>
+          <a:lstStyle/>
+          <a:p>
+            <a:pPr indent="0" marL="0">
+              <a:buNone/>
+            </a:pPr>
+            <a:r>
+              <a:rPr lang="en-US" sz="1150" b="1" dirty="0">
                 <a:solidFill>
                   <a:srgbClr val="22D3EE"/>
                 </a:solidFill>
@@ -6320,9 +6359,9 @@
                 <a:ea typeface="Calibri" pitchFamily="34" charset="-122"/>
                 <a:cs typeface="Calibri" pitchFamily="34" charset="-120"/>
               </a:rPr>
-              <a:t>Finance assistant</a:t>
-            </a:r>
-            <a:endParaRPr lang="en-US" sz="1200" dirty="0"/>
+              <a:t>Retrieval-grounded answers</a:t>
+            </a:r>
+            <a:endParaRPr lang="en-US" sz="1150" dirty="0"/>
           </a:p>
         </p:txBody>
       </p:sp>
@@ -6334,24 +6373,24 @@
         </p:nvSpPr>
         <p:spPr>
           <a:xfrm>
-            <a:off x="3236976" y="1481328"/>
-            <a:ext cx="2697480" cy="585216"/>
-          </a:xfrm>
-          <a:prstGeom prst="rect">
-            <a:avLst/>
-          </a:prstGeom>
-          <a:noFill/>
-          <a:ln/>
-        </p:spPr>
-        <p:txBody>
-          <a:bodyPr wrap="square" lIns="0" tIns="0" rIns="0" bIns="0" rtlCol="0" anchor="ctr"/>
-          <a:lstStyle/>
-          <a:p>
-            <a:pPr indent="0" marL="0">
-              <a:buNone/>
-            </a:pPr>
-            <a:r>
-              <a:rPr lang="en-US" sz="1050" dirty="0">
+            <a:off x="3236976" y="1389888"/>
+            <a:ext cx="2697480" cy="603504"/>
+          </a:xfrm>
+          <a:prstGeom prst="rect">
+            <a:avLst/>
+          </a:prstGeom>
+          <a:noFill/>
+          <a:ln/>
+        </p:spPr>
+        <p:txBody>
+          <a:bodyPr wrap="square" lIns="0" tIns="0" rIns="0" bIns="0" rtlCol="0" anchor="ctr"/>
+          <a:lstStyle/>
+          <a:p>
+            <a:pPr indent="0" marL="0">
+              <a:buNone/>
+            </a:pPr>
+            <a:r>
+              <a:rPr lang="en-US" sz="1000" dirty="0">
                 <a:solidFill>
                   <a:srgbClr val="F8FAFC"/>
                 </a:solidFill>
@@ -6359,9 +6398,9 @@
                 <a:ea typeface="Calibri" pitchFamily="34" charset="-122"/>
                 <a:cs typeface="Calibri" pitchFamily="34" charset="-120"/>
               </a:rPr>
-              <a:t>Answers free-text questions about the live model</a:t>
-            </a:r>
-            <a:endParaRPr lang="en-US" sz="1050" dirty="0"/>
+              <a:t>Retrieves the documentation passages bearing on a question before answering</a:t>
+            </a:r>
+            <a:endParaRPr lang="en-US" sz="1000" dirty="0"/>
           </a:p>
         </p:txBody>
       </p:sp>
@@ -6373,24 +6412,24 @@
         </p:nvSpPr>
         <p:spPr>
           <a:xfrm>
-            <a:off x="6236208" y="1481328"/>
-            <a:ext cx="2423160" cy="585216"/>
-          </a:xfrm>
-          <a:prstGeom prst="rect">
-            <a:avLst/>
-          </a:prstGeom>
-          <a:noFill/>
-          <a:ln/>
-        </p:spPr>
-        <p:txBody>
-          <a:bodyPr wrap="square" lIns="0" tIns="0" rIns="0" bIns="0" rtlCol="0" anchor="ctr"/>
-          <a:lstStyle/>
-          <a:p>
-            <a:pPr indent="0" marL="0">
-              <a:buNone/>
-            </a:pPr>
-            <a:r>
-              <a:rPr lang="en-US" sz="1000" dirty="0">
+            <a:off x="6236208" y="1389888"/>
+            <a:ext cx="2423160" cy="603504"/>
+          </a:xfrm>
+          <a:prstGeom prst="rect">
+            <a:avLst/>
+          </a:prstGeom>
+          <a:noFill/>
+          <a:ln/>
+        </p:spPr>
+        <p:txBody>
+          <a:bodyPr wrap="square" lIns="0" tIns="0" rIns="0" bIns="0" rtlCol="0" anchor="ctr"/>
+          <a:lstStyle/>
+          <a:p>
+            <a:pPr indent="0" marL="0">
+              <a:buNone/>
+            </a:pPr>
+            <a:r>
+              <a:rPr lang="en-US" sz="950" dirty="0">
                 <a:solidFill>
                   <a:srgbClr val="CADCFC"/>
                 </a:solidFill>
@@ -6398,9 +6437,9 @@
                 <a:ea typeface="Calibri" pitchFamily="34" charset="-122"/>
                 <a:cs typeface="Calibri" pitchFamily="34" charset="-120"/>
               </a:rPr>
-              <a:t>Assumptions and computed metrics as injected context</a:t>
-            </a:r>
-            <a:endParaRPr lang="en-US" sz="1000" dirty="0"/>
+              <a:t>A 112-passage corpus built from the methodology and assumption register</a:t>
+            </a:r>
+            <a:endParaRPr lang="en-US" sz="950" dirty="0"/>
           </a:p>
         </p:txBody>
       </p:sp>
@@ -6412,24 +6451,24 @@
         </p:nvSpPr>
         <p:spPr>
           <a:xfrm>
-            <a:off x="8961120" y="1481328"/>
-            <a:ext cx="2468880" cy="585216"/>
-          </a:xfrm>
-          <a:prstGeom prst="rect">
-            <a:avLst/>
-          </a:prstGeom>
-          <a:noFill/>
-          <a:ln/>
-        </p:spPr>
-        <p:txBody>
-          <a:bodyPr wrap="square" lIns="0" tIns="0" rIns="0" bIns="0" rtlCol="0" anchor="ctr"/>
-          <a:lstStyle/>
-          <a:p>
-            <a:pPr indent="0" marL="0">
-              <a:buNone/>
-            </a:pPr>
-            <a:r>
-              <a:rPr lang="en-US" sz="1000" i="1" dirty="0">
+            <a:off x="8961120" y="1389888"/>
+            <a:ext cx="2468880" cy="603504"/>
+          </a:xfrm>
+          <a:prstGeom prst="rect">
+            <a:avLst/>
+          </a:prstGeom>
+          <a:noFill/>
+          <a:ln/>
+        </p:spPr>
+        <p:txBody>
+          <a:bodyPr wrap="square" lIns="0" tIns="0" rIns="0" bIns="0" rtlCol="0" anchor="ctr"/>
+          <a:lstStyle/>
+          <a:p>
+            <a:pPr indent="0" marL="0">
+              <a:buNone/>
+            </a:pPr>
+            <a:r>
+              <a:rPr lang="en-US" sz="950" i="1" dirty="0">
                 <a:solidFill>
                   <a:srgbClr val="94A3B8"/>
                 </a:solidFill>
@@ -6437,9 +6476,9 @@
                 <a:ea typeface="Calibri" pitchFamily="34" charset="-122"/>
                 <a:cs typeface="Calibri" pitchFamily="34" charset="-120"/>
               </a:rPr>
-              <a:t>May misread ambiguous questions; not auditable line by line</a:t>
-            </a:r>
-            <a:endParaRPr lang="en-US" sz="1000" dirty="0"/>
+              <a:t>Retrieval can miss a passage; a citation proves provenance, not correctness</a:t>
+            </a:r>
+            <a:endParaRPr lang="en-US" sz="950" dirty="0"/>
           </a:p>
         </p:txBody>
       </p:sp>
@@ -6451,12 +6490,12 @@
         </p:nvSpPr>
         <p:spPr>
           <a:xfrm>
-            <a:off x="566928" y="2286000"/>
-            <a:ext cx="11057839" cy="768096"/>
+            <a:off x="566928" y="2139696"/>
+            <a:ext cx="11057839" cy="713232"/>
           </a:xfrm>
           <a:prstGeom prst="roundRect">
             <a:avLst>
-              <a:gd name="adj" fmla="val 11905"/>
+              <a:gd name="adj" fmla="val 12821"/>
             </a:avLst>
           </a:prstGeom>
           <a:solidFill>
@@ -6485,7 +6524,7 @@
         </p:nvSpPr>
         <p:spPr>
           <a:xfrm>
-            <a:off x="768096" y="2514600"/>
+            <a:off x="768096" y="2340864"/>
             <a:ext cx="310896" cy="310896"/>
           </a:xfrm>
           <a:prstGeom prst="ellipse">
@@ -6510,7 +6549,7 @@
         </p:nvSpPr>
         <p:spPr>
           <a:xfrm>
-            <a:off x="768096" y="2514600"/>
+            <a:off x="768096" y="2340864"/>
             <a:ext cx="310896" cy="310896"/>
           </a:xfrm>
           <a:prstGeom prst="rect">
@@ -6549,24 +6588,24 @@
         </p:nvSpPr>
         <p:spPr>
           <a:xfrm>
-            <a:off x="1188720" y="2340864"/>
-            <a:ext cx="2011680" cy="585216"/>
-          </a:xfrm>
-          <a:prstGeom prst="rect">
-            <a:avLst/>
-          </a:prstGeom>
-          <a:noFill/>
-          <a:ln/>
-        </p:spPr>
-        <p:txBody>
-          <a:bodyPr wrap="square" lIns="0" tIns="0" rIns="0" bIns="0" rtlCol="0" anchor="ctr"/>
-          <a:lstStyle/>
-          <a:p>
-            <a:pPr indent="0" marL="0">
-              <a:buNone/>
-            </a:pPr>
-            <a:r>
-              <a:rPr lang="en-US" sz="1200" b="1" dirty="0">
+            <a:off x="1188720" y="2194560"/>
+            <a:ext cx="2011680" cy="603504"/>
+          </a:xfrm>
+          <a:prstGeom prst="rect">
+            <a:avLst/>
+          </a:prstGeom>
+          <a:noFill/>
+          <a:ln/>
+        </p:spPr>
+        <p:txBody>
+          <a:bodyPr wrap="square" lIns="0" tIns="0" rIns="0" bIns="0" rtlCol="0" anchor="ctr"/>
+          <a:lstStyle/>
+          <a:p>
+            <a:pPr indent="0" marL="0">
+              <a:buNone/>
+            </a:pPr>
+            <a:r>
+              <a:rPr lang="en-US" sz="1150" b="1" dirty="0">
                 <a:solidFill>
                   <a:srgbClr val="22D3EE"/>
                 </a:solidFill>
@@ -6574,9 +6613,9 @@
                 <a:ea typeface="Calibri" pitchFamily="34" charset="-122"/>
                 <a:cs typeface="Calibri" pitchFamily="34" charset="-120"/>
               </a:rPr>
-              <a:t>Result explanation</a:t>
-            </a:r>
-            <a:endParaRPr lang="en-US" sz="1200" dirty="0"/>
+              <a:t>Finance assistant</a:t>
+            </a:r>
+            <a:endParaRPr lang="en-US" sz="1150" dirty="0"/>
           </a:p>
         </p:txBody>
       </p:sp>
@@ -6588,24 +6627,24 @@
         </p:nvSpPr>
         <p:spPr>
           <a:xfrm>
-            <a:off x="3236976" y="2340864"/>
-            <a:ext cx="2697480" cy="585216"/>
-          </a:xfrm>
-          <a:prstGeom prst="rect">
-            <a:avLst/>
-          </a:prstGeom>
-          <a:noFill/>
-          <a:ln/>
-        </p:spPr>
-        <p:txBody>
-          <a:bodyPr wrap="square" lIns="0" tIns="0" rIns="0" bIns="0" rtlCol="0" anchor="ctr"/>
-          <a:lstStyle/>
-          <a:p>
-            <a:pPr indent="0" marL="0">
-              <a:buNone/>
-            </a:pPr>
-            <a:r>
-              <a:rPr lang="en-US" sz="1050" dirty="0">
+            <a:off x="3236976" y="2194560"/>
+            <a:ext cx="2697480" cy="603504"/>
+          </a:xfrm>
+          <a:prstGeom prst="rect">
+            <a:avLst/>
+          </a:prstGeom>
+          <a:noFill/>
+          <a:ln/>
+        </p:spPr>
+        <p:txBody>
+          <a:bodyPr wrap="square" lIns="0" tIns="0" rIns="0" bIns="0" rtlCol="0" anchor="ctr"/>
+          <a:lstStyle/>
+          <a:p>
+            <a:pPr indent="0" marL="0">
+              <a:buNone/>
+            </a:pPr>
+            <a:r>
+              <a:rPr lang="en-US" sz="1000" dirty="0">
                 <a:solidFill>
                   <a:srgbClr val="F8FAFC"/>
                 </a:solidFill>
@@ -6613,9 +6652,9 @@
                 <a:ea typeface="Calibri" pitchFamily="34" charset="-122"/>
                 <a:cs typeface="Calibri" pitchFamily="34" charset="-120"/>
               </a:rPr>
-              <a:t>Explains why a metric moved</a:t>
-            </a:r>
-            <a:endParaRPr lang="en-US" sz="1050" dirty="0"/>
+              <a:t>Answers free-text questions about the live model</a:t>
+            </a:r>
+            <a:endParaRPr lang="en-US" sz="1000" dirty="0"/>
           </a:p>
         </p:txBody>
       </p:sp>
@@ -6627,24 +6666,24 @@
         </p:nvSpPr>
         <p:spPr>
           <a:xfrm>
-            <a:off x="6236208" y="2340864"/>
-            <a:ext cx="2423160" cy="585216"/>
-          </a:xfrm>
-          <a:prstGeom prst="rect">
-            <a:avLst/>
-          </a:prstGeom>
-          <a:noFill/>
-          <a:ln/>
-        </p:spPr>
-        <p:txBody>
-          <a:bodyPr wrap="square" lIns="0" tIns="0" rIns="0" bIns="0" rtlCol="0" anchor="ctr"/>
-          <a:lstStyle/>
-          <a:p>
-            <a:pPr indent="0" marL="0">
-              <a:buNone/>
-            </a:pPr>
-            <a:r>
-              <a:rPr lang="en-US" sz="1000" dirty="0">
+            <a:off x="6236208" y="2194560"/>
+            <a:ext cx="2423160" cy="603504"/>
+          </a:xfrm>
+          <a:prstGeom prst="rect">
+            <a:avLst/>
+          </a:prstGeom>
+          <a:noFill/>
+          <a:ln/>
+        </p:spPr>
+        <p:txBody>
+          <a:bodyPr wrap="square" lIns="0" tIns="0" rIns="0" bIns="0" rtlCol="0" anchor="ctr"/>
+          <a:lstStyle/>
+          <a:p>
+            <a:pPr indent="0" marL="0">
+              <a:buNone/>
+            </a:pPr>
+            <a:r>
+              <a:rPr lang="en-US" sz="950" dirty="0">
                 <a:solidFill>
                   <a:srgbClr val="CADCFC"/>
                 </a:solidFill>
@@ -6652,9 +6691,9 @@
                 <a:ea typeface="Calibri" pitchFamily="34" charset="-122"/>
                 <a:cs typeface="Calibri" pitchFamily="34" charset="-120"/>
               </a:rPr>
-              <a:t>Before-and-after metric pair</a:t>
-            </a:r>
-            <a:endParaRPr lang="en-US" sz="1000" dirty="0"/>
+              <a:t>Assumptions and computed metrics as injected context</a:t>
+            </a:r>
+            <a:endParaRPr lang="en-US" sz="950" dirty="0"/>
           </a:p>
         </p:txBody>
       </p:sp>
@@ -6666,24 +6705,24 @@
         </p:nvSpPr>
         <p:spPr>
           <a:xfrm>
-            <a:off x="8961120" y="2340864"/>
-            <a:ext cx="2468880" cy="585216"/>
-          </a:xfrm>
-          <a:prstGeom prst="rect">
-            <a:avLst/>
-          </a:prstGeom>
-          <a:noFill/>
-          <a:ln/>
-        </p:spPr>
-        <p:txBody>
-          <a:bodyPr wrap="square" lIns="0" tIns="0" rIns="0" bIns="0" rtlCol="0" anchor="ctr"/>
-          <a:lstStyle/>
-          <a:p>
-            <a:pPr indent="0" marL="0">
-              <a:buNone/>
-            </a:pPr>
-            <a:r>
-              <a:rPr lang="en-US" sz="1000" i="1" dirty="0">
+            <a:off x="8961120" y="2194560"/>
+            <a:ext cx="2468880" cy="603504"/>
+          </a:xfrm>
+          <a:prstGeom prst="rect">
+            <a:avLst/>
+          </a:prstGeom>
+          <a:noFill/>
+          <a:ln/>
+        </p:spPr>
+        <p:txBody>
+          <a:bodyPr wrap="square" lIns="0" tIns="0" rIns="0" bIns="0" rtlCol="0" anchor="ctr"/>
+          <a:lstStyle/>
+          <a:p>
+            <a:pPr indent="0" marL="0">
+              <a:buNone/>
+            </a:pPr>
+            <a:r>
+              <a:rPr lang="en-US" sz="950" i="1" dirty="0">
                 <a:solidFill>
                   <a:srgbClr val="94A3B8"/>
                 </a:solidFill>
@@ -6691,9 +6730,9 @@
                 <a:ea typeface="Calibri" pitchFamily="34" charset="-122"/>
                 <a:cs typeface="Calibri" pitchFamily="34" charset="-120"/>
               </a:rPr>
-              <a:t>Correlation can be narrated as causation</a:t>
-            </a:r>
-            <a:endParaRPr lang="en-US" sz="1000" dirty="0"/>
+              <a:t>May misread ambiguous questions; not auditable line by line</a:t>
+            </a:r>
+            <a:endParaRPr lang="en-US" sz="950" dirty="0"/>
           </a:p>
         </p:txBody>
       </p:sp>
@@ -6705,12 +6744,12 @@
         </p:nvSpPr>
         <p:spPr>
           <a:xfrm>
-            <a:off x="566928" y="3145536"/>
-            <a:ext cx="11057839" cy="768096"/>
+            <a:off x="566928" y="2944368"/>
+            <a:ext cx="11057839" cy="713232"/>
           </a:xfrm>
           <a:prstGeom prst="roundRect">
             <a:avLst>
-              <a:gd name="adj" fmla="val 11905"/>
+              <a:gd name="adj" fmla="val 12821"/>
             </a:avLst>
           </a:prstGeom>
           <a:solidFill>
@@ -6739,7 +6778,7 @@
         </p:nvSpPr>
         <p:spPr>
           <a:xfrm>
-            <a:off x="768096" y="3374136"/>
+            <a:off x="768096" y="3145536"/>
             <a:ext cx="310896" cy="310896"/>
           </a:xfrm>
           <a:prstGeom prst="ellipse">
@@ -6764,7 +6803,7 @@
         </p:nvSpPr>
         <p:spPr>
           <a:xfrm>
-            <a:off x="768096" y="3374136"/>
+            <a:off x="768096" y="3145536"/>
             <a:ext cx="310896" cy="310896"/>
           </a:xfrm>
           <a:prstGeom prst="rect">
@@ -6803,24 +6842,24 @@
         </p:nvSpPr>
         <p:spPr>
           <a:xfrm>
-            <a:off x="1188720" y="3200400"/>
-            <a:ext cx="2011680" cy="585216"/>
-          </a:xfrm>
-          <a:prstGeom prst="rect">
-            <a:avLst/>
-          </a:prstGeom>
-          <a:noFill/>
-          <a:ln/>
-        </p:spPr>
-        <p:txBody>
-          <a:bodyPr wrap="square" lIns="0" tIns="0" rIns="0" bIns="0" rtlCol="0" anchor="ctr"/>
-          <a:lstStyle/>
-          <a:p>
-            <a:pPr indent="0" marL="0">
-              <a:buNone/>
-            </a:pPr>
-            <a:r>
-              <a:rPr lang="en-US" sz="1200" b="1" dirty="0">
+            <a:off x="1188720" y="2999232"/>
+            <a:ext cx="2011680" cy="603504"/>
+          </a:xfrm>
+          <a:prstGeom prst="rect">
+            <a:avLst/>
+          </a:prstGeom>
+          <a:noFill/>
+          <a:ln/>
+        </p:spPr>
+        <p:txBody>
+          <a:bodyPr wrap="square" lIns="0" tIns="0" rIns="0" bIns="0" rtlCol="0" anchor="ctr"/>
+          <a:lstStyle/>
+          <a:p>
+            <a:pPr indent="0" marL="0">
+              <a:buNone/>
+            </a:pPr>
+            <a:r>
+              <a:rPr lang="en-US" sz="1150" b="1" dirty="0">
                 <a:solidFill>
                   <a:srgbClr val="22D3EE"/>
                 </a:solidFill>
@@ -6828,9 +6867,9 @@
                 <a:ea typeface="Calibri" pitchFamily="34" charset="-122"/>
                 <a:cs typeface="Calibri" pitchFamily="34" charset="-120"/>
               </a:rPr>
-              <a:t>Board recommendation</a:t>
-            </a:r>
-            <a:endParaRPr lang="en-US" sz="1200" dirty="0"/>
+              <a:t>Result explanation</a:t>
+            </a:r>
+            <a:endParaRPr lang="en-US" sz="1150" dirty="0"/>
           </a:p>
         </p:txBody>
       </p:sp>
@@ -6842,24 +6881,24 @@
         </p:nvSpPr>
         <p:spPr>
           <a:xfrm>
-            <a:off x="3236976" y="3200400"/>
-            <a:ext cx="2697480" cy="585216"/>
-          </a:xfrm>
-          <a:prstGeom prst="rect">
-            <a:avLst/>
-          </a:prstGeom>
-          <a:noFill/>
-          <a:ln/>
-        </p:spPr>
-        <p:txBody>
-          <a:bodyPr wrap="square" lIns="0" tIns="0" rIns="0" bIns="0" rtlCol="0" anchor="ctr"/>
-          <a:lstStyle/>
-          <a:p>
-            <a:pPr indent="0" marL="0">
-              <a:buNone/>
-            </a:pPr>
-            <a:r>
-              <a:rPr lang="en-US" sz="1050" dirty="0">
+            <a:off x="3236976" y="2999232"/>
+            <a:ext cx="2697480" cy="603504"/>
+          </a:xfrm>
+          <a:prstGeom prst="rect">
+            <a:avLst/>
+          </a:prstGeom>
+          <a:noFill/>
+          <a:ln/>
+        </p:spPr>
+        <p:txBody>
+          <a:bodyPr wrap="square" lIns="0" tIns="0" rIns="0" bIns="0" rtlCol="0" anchor="ctr"/>
+          <a:lstStyle/>
+          <a:p>
+            <a:pPr indent="0" marL="0">
+              <a:buNone/>
+            </a:pPr>
+            <a:r>
+              <a:rPr lang="en-US" sz="1000" dirty="0">
                 <a:solidFill>
                   <a:srgbClr val="F8FAFC"/>
                 </a:solidFill>
@@ -6867,9 +6906,9 @@
                 <a:ea typeface="Calibri" pitchFamily="34" charset="-122"/>
                 <a:cs typeface="Calibri" pitchFamily="34" charset="-120"/>
               </a:rPr>
-              <a:t>Drafts a structured decision with drivers, risks and controls</a:t>
-            </a:r>
-            <a:endParaRPr lang="en-US" sz="1050" dirty="0"/>
+              <a:t>Explains why a metric moved</a:t>
+            </a:r>
+            <a:endParaRPr lang="en-US" sz="1000" dirty="0"/>
           </a:p>
         </p:txBody>
       </p:sp>
@@ -6881,24 +6920,24 @@
         </p:nvSpPr>
         <p:spPr>
           <a:xfrm>
-            <a:off x="6236208" y="3200400"/>
-            <a:ext cx="2423160" cy="585216"/>
-          </a:xfrm>
-          <a:prstGeom prst="rect">
-            <a:avLst/>
-          </a:prstGeom>
-          <a:noFill/>
-          <a:ln/>
-        </p:spPr>
-        <p:txBody>
-          <a:bodyPr wrap="square" lIns="0" tIns="0" rIns="0" bIns="0" rtlCol="0" anchor="ctr"/>
-          <a:lstStyle/>
-          <a:p>
-            <a:pPr indent="0" marL="0">
-              <a:buNone/>
-            </a:pPr>
-            <a:r>
-              <a:rPr lang="en-US" sz="1000" dirty="0">
+            <a:off x="6236208" y="2999232"/>
+            <a:ext cx="2423160" cy="603504"/>
+          </a:xfrm>
+          <a:prstGeom prst="rect">
+            <a:avLst/>
+          </a:prstGeom>
+          <a:noFill/>
+          <a:ln/>
+        </p:spPr>
+        <p:txBody>
+          <a:bodyPr wrap="square" lIns="0" tIns="0" rIns="0" bIns="0" rtlCol="0" anchor="ctr"/>
+          <a:lstStyle/>
+          <a:p>
+            <a:pPr indent="0" marL="0">
+              <a:buNone/>
+            </a:pPr>
+            <a:r>
+              <a:rPr lang="en-US" sz="950" dirty="0">
                 <a:solidFill>
                   <a:srgbClr val="CADCFC"/>
                 </a:solidFill>
@@ -6906,9 +6945,9 @@
                 <a:ea typeface="Calibri" pitchFamily="34" charset="-122"/>
                 <a:cs typeface="Calibri" pitchFamily="34" charset="-120"/>
               </a:rPr>
-              <a:t>Validated metrics, scenarios and risk alerts</a:t>
-            </a:r>
-            <a:endParaRPr lang="en-US" sz="1000" dirty="0"/>
+              <a:t>Before-and-after metric pair</a:t>
+            </a:r>
+            <a:endParaRPr lang="en-US" sz="950" dirty="0"/>
           </a:p>
         </p:txBody>
       </p:sp>
@@ -6920,24 +6959,24 @@
         </p:nvSpPr>
         <p:spPr>
           <a:xfrm>
-            <a:off x="8961120" y="3200400"/>
-            <a:ext cx="2468880" cy="585216"/>
-          </a:xfrm>
-          <a:prstGeom prst="rect">
-            <a:avLst/>
-          </a:prstGeom>
-          <a:noFill/>
-          <a:ln/>
-        </p:spPr>
-        <p:txBody>
-          <a:bodyPr wrap="square" lIns="0" tIns="0" rIns="0" bIns="0" rtlCol="0" anchor="ctr"/>
-          <a:lstStyle/>
-          <a:p>
-            <a:pPr indent="0" marL="0">
-              <a:buNone/>
-            </a:pPr>
-            <a:r>
-              <a:rPr lang="en-US" sz="1000" i="1" dirty="0">
+            <a:off x="8961120" y="2999232"/>
+            <a:ext cx="2468880" cy="603504"/>
+          </a:xfrm>
+          <a:prstGeom prst="rect">
+            <a:avLst/>
+          </a:prstGeom>
+          <a:noFill/>
+          <a:ln/>
+        </p:spPr>
+        <p:txBody>
+          <a:bodyPr wrap="square" lIns="0" tIns="0" rIns="0" bIns="0" rtlCol="0" anchor="ctr"/>
+          <a:lstStyle/>
+          <a:p>
+            <a:pPr indent="0" marL="0">
+              <a:buNone/>
+            </a:pPr>
+            <a:r>
+              <a:rPr lang="en-US" sz="950" i="1" dirty="0">
                 <a:solidFill>
                   <a:srgbClr val="94A3B8"/>
                 </a:solidFill>
@@ -6945,9 +6984,9 @@
                 <a:ea typeface="Calibri" pitchFamily="34" charset="-122"/>
                 <a:cs typeface="Calibri" pitchFamily="34" charset="-120"/>
               </a:rPr>
-              <a:t>Will write a confident memo from poor inputs — sign-off mandatory</a:t>
-            </a:r>
-            <a:endParaRPr lang="en-US" sz="1000" dirty="0"/>
+              <a:t>Correlation can be narrated as causation</a:t>
+            </a:r>
+            <a:endParaRPr lang="en-US" sz="950" dirty="0"/>
           </a:p>
         </p:txBody>
       </p:sp>
@@ -6959,12 +6998,12 @@
         </p:nvSpPr>
         <p:spPr>
           <a:xfrm>
-            <a:off x="566928" y="4005072"/>
-            <a:ext cx="11057839" cy="768096"/>
+            <a:off x="566928" y="3749040"/>
+            <a:ext cx="11057839" cy="713232"/>
           </a:xfrm>
           <a:prstGeom prst="roundRect">
             <a:avLst>
-              <a:gd name="adj" fmla="val 11905"/>
+              <a:gd name="adj" fmla="val 12821"/>
             </a:avLst>
           </a:prstGeom>
           <a:solidFill>
@@ -6993,7 +7032,7 @@
         </p:nvSpPr>
         <p:spPr>
           <a:xfrm>
-            <a:off x="768096" y="4233672"/>
+            <a:off x="768096" y="3950208"/>
             <a:ext cx="310896" cy="310896"/>
           </a:xfrm>
           <a:prstGeom prst="ellipse">
@@ -7018,7 +7057,7 @@
         </p:nvSpPr>
         <p:spPr>
           <a:xfrm>
-            <a:off x="768096" y="4233672"/>
+            <a:off x="768096" y="3950208"/>
             <a:ext cx="310896" cy="310896"/>
           </a:xfrm>
           <a:prstGeom prst="rect">
@@ -7057,24 +7096,24 @@
         </p:nvSpPr>
         <p:spPr>
           <a:xfrm>
-            <a:off x="1188720" y="4059936"/>
-            <a:ext cx="2011680" cy="585216"/>
-          </a:xfrm>
-          <a:prstGeom prst="rect">
-            <a:avLst/>
-          </a:prstGeom>
-          <a:noFill/>
-          <a:ln/>
-        </p:spPr>
-        <p:txBody>
-          <a:bodyPr wrap="square" lIns="0" tIns="0" rIns="0" bIns="0" rtlCol="0" anchor="ctr"/>
-          <a:lstStyle/>
-          <a:p>
-            <a:pPr indent="0" marL="0">
-              <a:buNone/>
-            </a:pPr>
-            <a:r>
-              <a:rPr lang="en-US" sz="1200" b="1" dirty="0">
+            <a:off x="1188720" y="3803904"/>
+            <a:ext cx="2011680" cy="603504"/>
+          </a:xfrm>
+          <a:prstGeom prst="rect">
+            <a:avLst/>
+          </a:prstGeom>
+          <a:noFill/>
+          <a:ln/>
+        </p:spPr>
+        <p:txBody>
+          <a:bodyPr wrap="square" lIns="0" tIns="0" rIns="0" bIns="0" rtlCol="0" anchor="ctr"/>
+          <a:lstStyle/>
+          <a:p>
+            <a:pPr indent="0" marL="0">
+              <a:buNone/>
+            </a:pPr>
+            <a:r>
+              <a:rPr lang="en-US" sz="1150" b="1" dirty="0">
                 <a:solidFill>
                   <a:srgbClr val="22D3EE"/>
                 </a:solidFill>
@@ -7082,9 +7121,9 @@
                 <a:ea typeface="Calibri" pitchFamily="34" charset="-122"/>
                 <a:cs typeface="Calibri" pitchFamily="34" charset="-120"/>
               </a:rPr>
-              <a:t>Threat radar</a:t>
-            </a:r>
-            <a:endParaRPr lang="en-US" sz="1200" dirty="0"/>
+              <a:t>Board recommendation</a:t>
+            </a:r>
+            <a:endParaRPr lang="en-US" sz="1150" dirty="0"/>
           </a:p>
         </p:txBody>
       </p:sp>
@@ -7096,24 +7135,24 @@
         </p:nvSpPr>
         <p:spPr>
           <a:xfrm>
-            <a:off x="3236976" y="4059936"/>
-            <a:ext cx="2697480" cy="585216"/>
-          </a:xfrm>
-          <a:prstGeom prst="rect">
-            <a:avLst/>
-          </a:prstGeom>
-          <a:noFill/>
-          <a:ln/>
-        </p:spPr>
-        <p:txBody>
-          <a:bodyPr wrap="square" lIns="0" tIns="0" rIns="0" bIns="0" rtlCol="0" anchor="ctr"/>
-          <a:lstStyle/>
-          <a:p>
-            <a:pPr indent="0" marL="0">
-              <a:buNone/>
-            </a:pPr>
-            <a:r>
-              <a:rPr lang="en-US" sz="1050" dirty="0">
+            <a:off x="3236976" y="3803904"/>
+            <a:ext cx="2697480" cy="603504"/>
+          </a:xfrm>
+          <a:prstGeom prst="rect">
+            <a:avLst/>
+          </a:prstGeom>
+          <a:noFill/>
+          <a:ln/>
+        </p:spPr>
+        <p:txBody>
+          <a:bodyPr wrap="square" lIns="0" tIns="0" rIns="0" bIns="0" rtlCol="0" anchor="ctr"/>
+          <a:lstStyle/>
+          <a:p>
+            <a:pPr indent="0" marL="0">
+              <a:buNone/>
+            </a:pPr>
+            <a:r>
+              <a:rPr lang="en-US" sz="1000" dirty="0">
                 <a:solidFill>
                   <a:srgbClr val="F8FAFC"/>
                 </a:solidFill>
@@ -7121,9 +7160,9 @@
                 <a:ea typeface="Calibri" pitchFamily="34" charset="-122"/>
                 <a:cs typeface="Calibri" pitchFamily="34" charset="-120"/>
               </a:rPr>
-              <a:t>Ranks risk axes specific to the investment archetype</a:t>
-            </a:r>
-            <a:endParaRPr lang="en-US" sz="1050" dirty="0"/>
+              <a:t>Drafts a structured decision with drivers, risks and controls</a:t>
+            </a:r>
+            <a:endParaRPr lang="en-US" sz="1000" dirty="0"/>
           </a:p>
         </p:txBody>
       </p:sp>
@@ -7135,24 +7174,24 @@
         </p:nvSpPr>
         <p:spPr>
           <a:xfrm>
-            <a:off x="6236208" y="4059936"/>
-            <a:ext cx="2423160" cy="585216"/>
-          </a:xfrm>
-          <a:prstGeom prst="rect">
-            <a:avLst/>
-          </a:prstGeom>
-          <a:noFill/>
-          <a:ln/>
-        </p:spPr>
-        <p:txBody>
-          <a:bodyPr wrap="square" lIns="0" tIns="0" rIns="0" bIns="0" rtlCol="0" anchor="ctr"/>
-          <a:lstStyle/>
-          <a:p>
-            <a:pPr indent="0" marL="0">
-              <a:buNone/>
-            </a:pPr>
-            <a:r>
-              <a:rPr lang="en-US" sz="1000" dirty="0">
+            <a:off x="6236208" y="3803904"/>
+            <a:ext cx="2423160" cy="603504"/>
+          </a:xfrm>
+          <a:prstGeom prst="rect">
+            <a:avLst/>
+          </a:prstGeom>
+          <a:noFill/>
+          <a:ln/>
+        </p:spPr>
+        <p:txBody>
+          <a:bodyPr wrap="square" lIns="0" tIns="0" rIns="0" bIns="0" rtlCol="0" anchor="ctr"/>
+          <a:lstStyle/>
+          <a:p>
+            <a:pPr indent="0" marL="0">
+              <a:buNone/>
+            </a:pPr>
+            <a:r>
+              <a:rPr lang="en-US" sz="950" dirty="0">
                 <a:solidFill>
                   <a:srgbClr val="CADCFC"/>
                 </a:solidFill>
@@ -7160,9 +7199,9 @@
                 <a:ea typeface="Calibri" pitchFamily="34" charset="-122"/>
                 <a:cs typeface="Calibri" pitchFamily="34" charset="-120"/>
               </a:rPr>
-              <a:t>Archetype profile plus computed metrics</a:t>
-            </a:r>
-            <a:endParaRPr lang="en-US" sz="1000" dirty="0"/>
+              <a:t>Validated metrics, scenarios and risk alerts</a:t>
+            </a:r>
+            <a:endParaRPr lang="en-US" sz="950" dirty="0"/>
           </a:p>
         </p:txBody>
       </p:sp>
@@ -7174,24 +7213,24 @@
         </p:nvSpPr>
         <p:spPr>
           <a:xfrm>
-            <a:off x="8961120" y="4059936"/>
-            <a:ext cx="2468880" cy="585216"/>
-          </a:xfrm>
-          <a:prstGeom prst="rect">
-            <a:avLst/>
-          </a:prstGeom>
-          <a:noFill/>
-          <a:ln/>
-        </p:spPr>
-        <p:txBody>
-          <a:bodyPr wrap="square" lIns="0" tIns="0" rIns="0" bIns="0" rtlCol="0" anchor="ctr"/>
-          <a:lstStyle/>
-          <a:p>
-            <a:pPr indent="0" marL="0">
-              <a:buNone/>
-            </a:pPr>
-            <a:r>
-              <a:rPr lang="en-US" sz="1000" i="1" dirty="0">
+            <a:off x="8961120" y="3803904"/>
+            <a:ext cx="2468880" cy="603504"/>
+          </a:xfrm>
+          <a:prstGeom prst="rect">
+            <a:avLst/>
+          </a:prstGeom>
+          <a:noFill/>
+          <a:ln/>
+        </p:spPr>
+        <p:txBody>
+          <a:bodyPr wrap="square" lIns="0" tIns="0" rIns="0" bIns="0" rtlCol="0" anchor="ctr"/>
+          <a:lstStyle/>
+          <a:p>
+            <a:pPr indent="0" marL="0">
+              <a:buNone/>
+            </a:pPr>
+            <a:r>
+              <a:rPr lang="en-US" sz="950" i="1" dirty="0">
                 <a:solidFill>
                   <a:srgbClr val="94A3B8"/>
                 </a:solidFill>
@@ -7199,9 +7238,9 @@
                 <a:ea typeface="Calibri" pitchFamily="34" charset="-122"/>
                 <a:cs typeface="Calibri" pitchFamily="34" charset="-120"/>
               </a:rPr>
-              <a:t>Only detects risks encoded in its priors</a:t>
-            </a:r>
-            <a:endParaRPr lang="en-US" sz="1000" dirty="0"/>
+              <a:t>Will write a confident memo from poor inputs — sign-off mandatory</a:t>
+            </a:r>
+            <a:endParaRPr lang="en-US" sz="950" dirty="0"/>
           </a:p>
         </p:txBody>
       </p:sp>
@@ -7213,12 +7252,12 @@
         </p:nvSpPr>
         <p:spPr>
           <a:xfrm>
-            <a:off x="566928" y="4864608"/>
-            <a:ext cx="11057839" cy="768096"/>
+            <a:off x="566928" y="4553712"/>
+            <a:ext cx="11057839" cy="713232"/>
           </a:xfrm>
           <a:prstGeom prst="roundRect">
             <a:avLst>
-              <a:gd name="adj" fmla="val 11905"/>
+              <a:gd name="adj" fmla="val 12821"/>
             </a:avLst>
           </a:prstGeom>
           <a:solidFill>
@@ -7247,7 +7286,7 @@
         </p:nvSpPr>
         <p:spPr>
           <a:xfrm>
-            <a:off x="768096" y="5093208"/>
+            <a:off x="768096" y="4754880"/>
             <a:ext cx="310896" cy="310896"/>
           </a:xfrm>
           <a:prstGeom prst="ellipse">
@@ -7272,7 +7311,7 @@
         </p:nvSpPr>
         <p:spPr>
           <a:xfrm>
-            <a:off x="768096" y="5093208"/>
+            <a:off x="768096" y="4754880"/>
             <a:ext cx="310896" cy="310896"/>
           </a:xfrm>
           <a:prstGeom prst="rect">
@@ -7311,24 +7350,24 @@
         </p:nvSpPr>
         <p:spPr>
           <a:xfrm>
-            <a:off x="1188720" y="4919472"/>
-            <a:ext cx="2011680" cy="585216"/>
-          </a:xfrm>
-          <a:prstGeom prst="rect">
-            <a:avLst/>
-          </a:prstGeom>
-          <a:noFill/>
-          <a:ln/>
-        </p:spPr>
-        <p:txBody>
-          <a:bodyPr wrap="square" lIns="0" tIns="0" rIns="0" bIns="0" rtlCol="0" anchor="ctr"/>
-          <a:lstStyle/>
-          <a:p>
-            <a:pPr indent="0" marL="0">
-              <a:buNone/>
-            </a:pPr>
-            <a:r>
-              <a:rPr lang="en-US" sz="1200" b="1" dirty="0">
+            <a:off x="1188720" y="4608576"/>
+            <a:ext cx="2011680" cy="603504"/>
+          </a:xfrm>
+          <a:prstGeom prst="rect">
+            <a:avLst/>
+          </a:prstGeom>
+          <a:noFill/>
+          <a:ln/>
+        </p:spPr>
+        <p:txBody>
+          <a:bodyPr wrap="square" lIns="0" tIns="0" rIns="0" bIns="0" rtlCol="0" anchor="ctr"/>
+          <a:lstStyle/>
+          <a:p>
+            <a:pPr indent="0" marL="0">
+              <a:buNone/>
+            </a:pPr>
+            <a:r>
+              <a:rPr lang="en-US" sz="1150" b="1" dirty="0">
                 <a:solidFill>
                   <a:srgbClr val="22D3EE"/>
                 </a:solidFill>
@@ -7336,38 +7375,292 @@
                 <a:ea typeface="Calibri" pitchFamily="34" charset="-122"/>
                 <a:cs typeface="Calibri" pitchFamily="34" charset="-120"/>
               </a:rPr>
+              <a:t>Threat radar</a:t>
+            </a:r>
+            <a:endParaRPr lang="en-US" sz="1150" dirty="0"/>
+          </a:p>
+        </p:txBody>
+      </p:sp>
+      <p:sp>
+        <p:nvSpPr>
+          <p:cNvPr id="38" name="Text 36"/>
+          <p:cNvSpPr/>
+          <p:nvPr/>
+        </p:nvSpPr>
+        <p:spPr>
+          <a:xfrm>
+            <a:off x="3236976" y="4608576"/>
+            <a:ext cx="2697480" cy="603504"/>
+          </a:xfrm>
+          <a:prstGeom prst="rect">
+            <a:avLst/>
+          </a:prstGeom>
+          <a:noFill/>
+          <a:ln/>
+        </p:spPr>
+        <p:txBody>
+          <a:bodyPr wrap="square" lIns="0" tIns="0" rIns="0" bIns="0" rtlCol="0" anchor="ctr"/>
+          <a:lstStyle/>
+          <a:p>
+            <a:pPr indent="0" marL="0">
+              <a:buNone/>
+            </a:pPr>
+            <a:r>
+              <a:rPr lang="en-US" sz="1000" dirty="0">
+                <a:solidFill>
+                  <a:srgbClr val="F8FAFC"/>
+                </a:solidFill>
+                <a:latin typeface="Calibri" pitchFamily="34" charset="0"/>
+                <a:ea typeface="Calibri" pitchFamily="34" charset="-122"/>
+                <a:cs typeface="Calibri" pitchFamily="34" charset="-120"/>
+              </a:rPr>
+              <a:t>Ranks risk axes specific to the investment archetype</a:t>
+            </a:r>
+            <a:endParaRPr lang="en-US" sz="1000" dirty="0"/>
+          </a:p>
+        </p:txBody>
+      </p:sp>
+      <p:sp>
+        <p:nvSpPr>
+          <p:cNvPr id="39" name="Text 37"/>
+          <p:cNvSpPr/>
+          <p:nvPr/>
+        </p:nvSpPr>
+        <p:spPr>
+          <a:xfrm>
+            <a:off x="6236208" y="4608576"/>
+            <a:ext cx="2423160" cy="603504"/>
+          </a:xfrm>
+          <a:prstGeom prst="rect">
+            <a:avLst/>
+          </a:prstGeom>
+          <a:noFill/>
+          <a:ln/>
+        </p:spPr>
+        <p:txBody>
+          <a:bodyPr wrap="square" lIns="0" tIns="0" rIns="0" bIns="0" rtlCol="0" anchor="ctr"/>
+          <a:lstStyle/>
+          <a:p>
+            <a:pPr indent="0" marL="0">
+              <a:buNone/>
+            </a:pPr>
+            <a:r>
+              <a:rPr lang="en-US" sz="950" dirty="0">
+                <a:solidFill>
+                  <a:srgbClr val="CADCFC"/>
+                </a:solidFill>
+                <a:latin typeface="Calibri" pitchFamily="34" charset="0"/>
+                <a:ea typeface="Calibri" pitchFamily="34" charset="-122"/>
+                <a:cs typeface="Calibri" pitchFamily="34" charset="-120"/>
+              </a:rPr>
+              <a:t>Archetype profile plus computed metrics</a:t>
+            </a:r>
+            <a:endParaRPr lang="en-US" sz="950" dirty="0"/>
+          </a:p>
+        </p:txBody>
+      </p:sp>
+      <p:sp>
+        <p:nvSpPr>
+          <p:cNvPr id="40" name="Text 38"/>
+          <p:cNvSpPr/>
+          <p:nvPr/>
+        </p:nvSpPr>
+        <p:spPr>
+          <a:xfrm>
+            <a:off x="8961120" y="4608576"/>
+            <a:ext cx="2468880" cy="603504"/>
+          </a:xfrm>
+          <a:prstGeom prst="rect">
+            <a:avLst/>
+          </a:prstGeom>
+          <a:noFill/>
+          <a:ln/>
+        </p:spPr>
+        <p:txBody>
+          <a:bodyPr wrap="square" lIns="0" tIns="0" rIns="0" bIns="0" rtlCol="0" anchor="ctr"/>
+          <a:lstStyle/>
+          <a:p>
+            <a:pPr indent="0" marL="0">
+              <a:buNone/>
+            </a:pPr>
+            <a:r>
+              <a:rPr lang="en-US" sz="950" i="1" dirty="0">
+                <a:solidFill>
+                  <a:srgbClr val="94A3B8"/>
+                </a:solidFill>
+                <a:latin typeface="Calibri" pitchFamily="34" charset="0"/>
+                <a:ea typeface="Calibri" pitchFamily="34" charset="-122"/>
+                <a:cs typeface="Calibri" pitchFamily="34" charset="-120"/>
+              </a:rPr>
+              <a:t>Only detects risks encoded in its priors</a:t>
+            </a:r>
+            <a:endParaRPr lang="en-US" sz="950" dirty="0"/>
+          </a:p>
+        </p:txBody>
+      </p:sp>
+      <p:sp>
+        <p:nvSpPr>
+          <p:cNvPr id="41" name="Shape 39"/>
+          <p:cNvSpPr/>
+          <p:nvPr/>
+        </p:nvSpPr>
+        <p:spPr>
+          <a:xfrm>
+            <a:off x="566928" y="5358384"/>
+            <a:ext cx="11057839" cy="713232"/>
+          </a:xfrm>
+          <a:prstGeom prst="roundRect">
+            <a:avLst>
+              <a:gd name="adj" fmla="val 12821"/>
+            </a:avLst>
+          </a:prstGeom>
+          <a:solidFill>
+            <a:srgbClr val="0F2740"/>
+          </a:solidFill>
+          <a:ln w="12700">
+            <a:solidFill>
+              <a:srgbClr val="1E4463"/>
+            </a:solidFill>
+            <a:prstDash val="solid"/>
+          </a:ln>
+          <a:effectLst>
+            <a:outerShdw sx="100000" sy="100000" kx="0" ky="0" algn="bl" rotWithShape="0" blurRad="177800" dist="38100" dir="5400000">
+              <a:srgbClr val="000000">
+                <a:alpha val="35000"/>
+              </a:srgbClr>
+            </a:outerShdw>
+          </a:effectLst>
+        </p:spPr>
+      </p:sp>
+      <p:sp>
+        <p:nvSpPr>
+          <p:cNvPr id="42" name="Shape 40"/>
+          <p:cNvSpPr/>
+          <p:nvPr/>
+        </p:nvSpPr>
+        <p:spPr>
+          <a:xfrm>
+            <a:off x="768096" y="5559552"/>
+            <a:ext cx="310896" cy="310896"/>
+          </a:xfrm>
+          <a:prstGeom prst="ellipse">
+            <a:avLst/>
+          </a:prstGeom>
+          <a:solidFill>
+            <a:srgbClr val="22D3EE"/>
+          </a:solidFill>
+          <a:ln w="12700">
+            <a:solidFill>
+              <a:srgbClr val="22D3EE"/>
+            </a:solidFill>
+            <a:prstDash val="solid"/>
+          </a:ln>
+        </p:spPr>
+      </p:sp>
+      <p:sp>
+        <p:nvSpPr>
+          <p:cNvPr id="43" name="Text 41"/>
+          <p:cNvSpPr/>
+          <p:nvPr/>
+        </p:nvSpPr>
+        <p:spPr>
+          <a:xfrm>
+            <a:off x="768096" y="5559552"/>
+            <a:ext cx="310896" cy="310896"/>
+          </a:xfrm>
+          <a:prstGeom prst="rect">
+            <a:avLst/>
+          </a:prstGeom>
+          <a:noFill/>
+          <a:ln/>
+        </p:spPr>
+        <p:txBody>
+          <a:bodyPr wrap="square" lIns="0" tIns="0" rIns="0" bIns="0" rtlCol="0" anchor="ctr"/>
+          <a:lstStyle/>
+          <a:p>
+            <a:pPr algn="ctr" indent="0" marL="0">
+              <a:buNone/>
+            </a:pPr>
+            <a:r>
+              <a:rPr lang="en-US" sz="1300" b="1" dirty="0">
+                <a:solidFill>
+                  <a:srgbClr val="0B1A2E"/>
+                </a:solidFill>
+                <a:latin typeface="Calibri" pitchFamily="34" charset="0"/>
+                <a:ea typeface="Calibri" pitchFamily="34" charset="-122"/>
+                <a:cs typeface="Calibri" pitchFamily="34" charset="-120"/>
+              </a:rPr>
+              <a:t>6</a:t>
+            </a:r>
+            <a:endParaRPr lang="en-US" sz="1300" dirty="0"/>
+          </a:p>
+        </p:txBody>
+      </p:sp>
+      <p:sp>
+        <p:nvSpPr>
+          <p:cNvPr id="44" name="Text 42"/>
+          <p:cNvSpPr/>
+          <p:nvPr/>
+        </p:nvSpPr>
+        <p:spPr>
+          <a:xfrm>
+            <a:off x="1188720" y="5413248"/>
+            <a:ext cx="2011680" cy="603504"/>
+          </a:xfrm>
+          <a:prstGeom prst="rect">
+            <a:avLst/>
+          </a:prstGeom>
+          <a:noFill/>
+          <a:ln/>
+        </p:spPr>
+        <p:txBody>
+          <a:bodyPr wrap="square" lIns="0" tIns="0" rIns="0" bIns="0" rtlCol="0" anchor="ctr"/>
+          <a:lstStyle/>
+          <a:p>
+            <a:pPr indent="0" marL="0">
+              <a:buNone/>
+            </a:pPr>
+            <a:r>
+              <a:rPr lang="en-US" sz="1150" b="1" dirty="0">
+                <a:solidFill>
+                  <a:srgbClr val="22D3EE"/>
+                </a:solidFill>
+                <a:latin typeface="Calibri" pitchFamily="34" charset="0"/>
+                <a:ea typeface="Calibri" pitchFamily="34" charset="-122"/>
+                <a:cs typeface="Calibri" pitchFamily="34" charset="-120"/>
+              </a:rPr>
               <a:t>Board debate</a:t>
             </a:r>
-            <a:endParaRPr lang="en-US" sz="1200" dirty="0"/>
-          </a:p>
-        </p:txBody>
-      </p:sp>
-      <p:sp>
-        <p:nvSpPr>
-          <p:cNvPr id="38" name="Text 36"/>
-          <p:cNvSpPr/>
-          <p:nvPr/>
-        </p:nvSpPr>
-        <p:spPr>
-          <a:xfrm>
-            <a:off x="3236976" y="4919472"/>
-            <a:ext cx="2697480" cy="585216"/>
-          </a:xfrm>
-          <a:prstGeom prst="rect">
-            <a:avLst/>
-          </a:prstGeom>
-          <a:noFill/>
-          <a:ln/>
-        </p:spPr>
-        <p:txBody>
-          <a:bodyPr wrap="square" lIns="0" tIns="0" rIns="0" bIns="0" rtlCol="0" anchor="ctr"/>
-          <a:lstStyle/>
-          <a:p>
-            <a:pPr indent="0" marL="0">
-              <a:buNone/>
-            </a:pPr>
-            <a:r>
-              <a:rPr lang="en-US" sz="1050" dirty="0">
+            <a:endParaRPr lang="en-US" sz="1150" dirty="0"/>
+          </a:p>
+        </p:txBody>
+      </p:sp>
+      <p:sp>
+        <p:nvSpPr>
+          <p:cNvPr id="45" name="Text 43"/>
+          <p:cNvSpPr/>
+          <p:nvPr/>
+        </p:nvSpPr>
+        <p:spPr>
+          <a:xfrm>
+            <a:off x="3236976" y="5413248"/>
+            <a:ext cx="2697480" cy="603504"/>
+          </a:xfrm>
+          <a:prstGeom prst="rect">
+            <a:avLst/>
+          </a:prstGeom>
+          <a:noFill/>
+          <a:ln/>
+        </p:spPr>
+        <p:txBody>
+          <a:bodyPr wrap="square" lIns="0" tIns="0" rIns="0" bIns="0" rtlCol="0" anchor="ctr"/>
+          <a:lstStyle/>
+          <a:p>
+            <a:pPr indent="0" marL="0">
+              <a:buNone/>
+            </a:pPr>
+            <a:r>
+              <a:rPr lang="en-US" sz="1000" dirty="0">
                 <a:solidFill>
                   <a:srgbClr val="F8FAFC"/>
                 </a:solidFill>
@@ -7377,36 +7670,36 @@
               </a:rPr>
               <a:t>Simulates CFO, COO, Risk Officer and a sceptical non-executive</a:t>
             </a:r>
-            <a:endParaRPr lang="en-US" sz="1050" dirty="0"/>
-          </a:p>
-        </p:txBody>
-      </p:sp>
-      <p:sp>
-        <p:nvSpPr>
-          <p:cNvPr id="39" name="Text 37"/>
-          <p:cNvSpPr/>
-          <p:nvPr/>
-        </p:nvSpPr>
-        <p:spPr>
-          <a:xfrm>
-            <a:off x="6236208" y="4919472"/>
-            <a:ext cx="2423160" cy="585216"/>
-          </a:xfrm>
-          <a:prstGeom prst="rect">
-            <a:avLst/>
-          </a:prstGeom>
-          <a:noFill/>
-          <a:ln/>
-        </p:spPr>
-        <p:txBody>
-          <a:bodyPr wrap="square" lIns="0" tIns="0" rIns="0" bIns="0" rtlCol="0" anchor="ctr"/>
-          <a:lstStyle/>
-          <a:p>
-            <a:pPr indent="0" marL="0">
-              <a:buNone/>
-            </a:pPr>
-            <a:r>
-              <a:rPr lang="en-US" sz="1000" dirty="0">
+            <a:endParaRPr lang="en-US" sz="1000" dirty="0"/>
+          </a:p>
+        </p:txBody>
+      </p:sp>
+      <p:sp>
+        <p:nvSpPr>
+          <p:cNvPr id="46" name="Text 44"/>
+          <p:cNvSpPr/>
+          <p:nvPr/>
+        </p:nvSpPr>
+        <p:spPr>
+          <a:xfrm>
+            <a:off x="6236208" y="5413248"/>
+            <a:ext cx="2423160" cy="603504"/>
+          </a:xfrm>
+          <a:prstGeom prst="rect">
+            <a:avLst/>
+          </a:prstGeom>
+          <a:noFill/>
+          <a:ln/>
+        </p:spPr>
+        <p:txBody>
+          <a:bodyPr wrap="square" lIns="0" tIns="0" rIns="0" bIns="0" rtlCol="0" anchor="ctr"/>
+          <a:lstStyle/>
+          <a:p>
+            <a:pPr indent="0" marL="0">
+              <a:buNone/>
+            </a:pPr>
+            <a:r>
+              <a:rPr lang="en-US" sz="950" dirty="0">
                 <a:solidFill>
                   <a:srgbClr val="CADCFC"/>
                 </a:solidFill>
@@ -7416,36 +7709,36 @@
               </a:rPr>
               <a:t>Metrics, scenario set, archetype persona slants</a:t>
             </a:r>
-            <a:endParaRPr lang="en-US" sz="1000" dirty="0"/>
-          </a:p>
-        </p:txBody>
-      </p:sp>
-      <p:sp>
-        <p:nvSpPr>
-          <p:cNvPr id="40" name="Text 38"/>
-          <p:cNvSpPr/>
-          <p:nvPr/>
-        </p:nvSpPr>
-        <p:spPr>
-          <a:xfrm>
-            <a:off x="8961120" y="4919472"/>
-            <a:ext cx="2468880" cy="585216"/>
-          </a:xfrm>
-          <a:prstGeom prst="rect">
-            <a:avLst/>
-          </a:prstGeom>
-          <a:noFill/>
-          <a:ln/>
-        </p:spPr>
-        <p:txBody>
-          <a:bodyPr wrap="square" lIns="0" tIns="0" rIns="0" bIns="0" rtlCol="0" anchor="ctr"/>
-          <a:lstStyle/>
-          <a:p>
-            <a:pPr indent="0" marL="0">
-              <a:buNone/>
-            </a:pPr>
-            <a:r>
-              <a:rPr lang="en-US" sz="1000" i="1" dirty="0">
+            <a:endParaRPr lang="en-US" sz="950" dirty="0"/>
+          </a:p>
+        </p:txBody>
+      </p:sp>
+      <p:sp>
+        <p:nvSpPr>
+          <p:cNvPr id="47" name="Text 45"/>
+          <p:cNvSpPr/>
+          <p:nvPr/>
+        </p:nvSpPr>
+        <p:spPr>
+          <a:xfrm>
+            <a:off x="8961120" y="5413248"/>
+            <a:ext cx="2468880" cy="603504"/>
+          </a:xfrm>
+          <a:prstGeom prst="rect">
+            <a:avLst/>
+          </a:prstGeom>
+          <a:noFill/>
+          <a:ln/>
+        </p:spPr>
+        <p:txBody>
+          <a:bodyPr wrap="square" lIns="0" tIns="0" rIns="0" bIns="0" rtlCol="0" anchor="ctr"/>
+          <a:lstStyle/>
+          <a:p>
+            <a:pPr indent="0" marL="0">
+              <a:buNone/>
+            </a:pPr>
+            <a:r>
+              <a:rPr lang="en-US" sz="950" i="1" dirty="0">
                 <a:solidFill>
                   <a:srgbClr val="94A3B8"/>
                 </a:solidFill>
@@ -7455,19 +7748,19 @@
               </a:rPr>
               <a:t>Simulated dissent is not real governance</a:t>
             </a:r>
-            <a:endParaRPr lang="en-US" sz="1000" dirty="0"/>
-          </a:p>
-        </p:txBody>
-      </p:sp>
-      <p:sp>
-        <p:nvSpPr>
-          <p:cNvPr id="41" name="Text 39"/>
-          <p:cNvSpPr/>
-          <p:nvPr/>
-        </p:nvSpPr>
-        <p:spPr>
-          <a:xfrm>
-            <a:off x="1188720" y="1188720"/>
+            <a:endParaRPr lang="en-US" sz="950" dirty="0"/>
+          </a:p>
+        </p:txBody>
+      </p:sp>
+      <p:sp>
+        <p:nvSpPr>
+          <p:cNvPr id="48" name="Text 46"/>
+          <p:cNvSpPr/>
+          <p:nvPr/>
+        </p:nvSpPr>
+        <p:spPr>
+          <a:xfrm>
+            <a:off x="1188720" y="1133856"/>
             <a:ext cx="2011680" cy="219456"/>
           </a:xfrm>
           <a:prstGeom prst="rect">
@@ -7500,13 +7793,13 @@
       </p:sp>
       <p:sp>
         <p:nvSpPr>
-          <p:cNvPr id="42" name="Text 40"/>
-          <p:cNvSpPr/>
-          <p:nvPr/>
-        </p:nvSpPr>
-        <p:spPr>
-          <a:xfrm>
-            <a:off x="3236976" y="1188720"/>
+          <p:cNvPr id="49" name="Text 47"/>
+          <p:cNvSpPr/>
+          <p:nvPr/>
+        </p:nvSpPr>
+        <p:spPr>
+          <a:xfrm>
+            <a:off x="3236976" y="1133856"/>
             <a:ext cx="2697480" cy="219456"/>
           </a:xfrm>
           <a:prstGeom prst="rect">
@@ -7539,13 +7832,13 @@
       </p:sp>
       <p:sp>
         <p:nvSpPr>
-          <p:cNvPr id="43" name="Text 41"/>
-          <p:cNvSpPr/>
-          <p:nvPr/>
-        </p:nvSpPr>
-        <p:spPr>
-          <a:xfrm>
-            <a:off x="6236208" y="1188720"/>
+          <p:cNvPr id="50" name="Text 48"/>
+          <p:cNvSpPr/>
+          <p:nvPr/>
+        </p:nvSpPr>
+        <p:spPr>
+          <a:xfrm>
+            <a:off x="6236208" y="1133856"/>
             <a:ext cx="2423160" cy="219456"/>
           </a:xfrm>
           <a:prstGeom prst="rect">
@@ -7578,13 +7871,13 @@
       </p:sp>
       <p:sp>
         <p:nvSpPr>
-          <p:cNvPr id="44" name="Text 42"/>
-          <p:cNvSpPr/>
-          <p:nvPr/>
-        </p:nvSpPr>
-        <p:spPr>
-          <a:xfrm>
-            <a:off x="8961120" y="1188720"/>
+          <p:cNvPr id="51" name="Text 49"/>
+          <p:cNvSpPr/>
+          <p:nvPr/>
+        </p:nvSpPr>
+        <p:spPr>
+          <a:xfrm>
+            <a:off x="8961120" y="1133856"/>
             <a:ext cx="2468880" cy="219456"/>
           </a:xfrm>
           <a:prstGeom prst="rect">
@@ -7719,7 +8012,7 @@
                 <a:ea typeface="Cambria" pitchFamily="34" charset="-122"/>
                 <a:cs typeface="Cambria" pitchFamily="34" charset="-120"/>
               </a:rPr>
-              <a:t>Ten AI capabilities — the second five</a:t>
+              <a:t>Twelve AI capabilities — the second six</a:t>
             </a:r>
             <a:endParaRPr lang="en-US" sz="3000" dirty="0"/>
           </a:p>
@@ -7799,12 +8092,12 @@
         </p:nvSpPr>
         <p:spPr>
           <a:xfrm>
-            <a:off x="566928" y="1335024"/>
-            <a:ext cx="11057839" cy="621792"/>
+            <a:off x="566928" y="1371600"/>
+            <a:ext cx="11057839" cy="566928"/>
           </a:xfrm>
           <a:prstGeom prst="roundRect">
             <a:avLst>
-              <a:gd name="adj" fmla="val 14706"/>
+              <a:gd name="adj" fmla="val 16129"/>
             </a:avLst>
           </a:prstGeom>
           <a:solidFill>
@@ -7833,7 +8126,7 @@
         </p:nvSpPr>
         <p:spPr>
           <a:xfrm>
-            <a:off x="768096" y="1481328"/>
+            <a:off x="768096" y="1499616"/>
             <a:ext cx="310896" cy="310896"/>
           </a:xfrm>
           <a:prstGeom prst="ellipse">
@@ -7858,7 +8151,7 @@
         </p:nvSpPr>
         <p:spPr>
           <a:xfrm>
-            <a:off x="768096" y="1481328"/>
+            <a:off x="768096" y="1499616"/>
             <a:ext cx="310896" cy="310896"/>
           </a:xfrm>
           <a:prstGeom prst="rect">
@@ -7883,7 +8176,7 @@
                 <a:ea typeface="Calibri" pitchFamily="34" charset="-122"/>
                 <a:cs typeface="Calibri" pitchFamily="34" charset="-120"/>
               </a:rPr>
-              <a:t>6</a:t>
+              <a:t>7</a:t>
             </a:r>
             <a:endParaRPr lang="en-US" sz="1300" dirty="0"/>
           </a:p>
@@ -7897,24 +8190,24 @@
         </p:nvSpPr>
         <p:spPr>
           <a:xfrm>
-            <a:off x="1188720" y="1380744"/>
-            <a:ext cx="2011680" cy="512064"/>
-          </a:xfrm>
-          <a:prstGeom prst="rect">
-            <a:avLst/>
-          </a:prstGeom>
-          <a:noFill/>
-          <a:ln/>
-        </p:spPr>
-        <p:txBody>
-          <a:bodyPr wrap="square" lIns="0" tIns="0" rIns="0" bIns="0" rtlCol="0" anchor="ctr"/>
-          <a:lstStyle/>
-          <a:p>
-            <a:pPr indent="0" marL="0">
-              <a:buNone/>
-            </a:pPr>
-            <a:r>
-              <a:rPr lang="en-US" sz="1200" b="1" dirty="0">
+            <a:off x="1188720" y="1408176"/>
+            <a:ext cx="2011680" cy="493776"/>
+          </a:xfrm>
+          <a:prstGeom prst="rect">
+            <a:avLst/>
+          </a:prstGeom>
+          <a:noFill/>
+          <a:ln/>
+        </p:spPr>
+        <p:txBody>
+          <a:bodyPr wrap="square" lIns="0" tIns="0" rIns="0" bIns="0" rtlCol="0" anchor="ctr"/>
+          <a:lstStyle/>
+          <a:p>
+            <a:pPr indent="0" marL="0">
+              <a:buNone/>
+            </a:pPr>
+            <a:r>
+              <a:rPr lang="en-US" sz="1150" b="1" dirty="0">
                 <a:solidFill>
                   <a:srgbClr val="22D3EE"/>
                 </a:solidFill>
@@ -7924,7 +8217,7 @@
               </a:rPr>
               <a:t>Board memorandum</a:t>
             </a:r>
-            <a:endParaRPr lang="en-US" sz="1200" dirty="0"/>
+            <a:endParaRPr lang="en-US" sz="1150" dirty="0"/>
           </a:p>
         </p:txBody>
       </p:sp>
@@ -7936,24 +8229,24 @@
         </p:nvSpPr>
         <p:spPr>
           <a:xfrm>
-            <a:off x="3236976" y="1380744"/>
-            <a:ext cx="2697480" cy="512064"/>
-          </a:xfrm>
-          <a:prstGeom prst="rect">
-            <a:avLst/>
-          </a:prstGeom>
-          <a:noFill/>
-          <a:ln/>
-        </p:spPr>
-        <p:txBody>
-          <a:bodyPr wrap="square" lIns="0" tIns="0" rIns="0" bIns="0" rtlCol="0" anchor="ctr"/>
-          <a:lstStyle/>
-          <a:p>
-            <a:pPr indent="0" marL="0">
-              <a:buNone/>
-            </a:pPr>
-            <a:r>
-              <a:rPr lang="en-US" sz="1050" dirty="0">
+            <a:off x="3236976" y="1408176"/>
+            <a:ext cx="2697480" cy="493776"/>
+          </a:xfrm>
+          <a:prstGeom prst="rect">
+            <a:avLst/>
+          </a:prstGeom>
+          <a:noFill/>
+          <a:ln/>
+        </p:spPr>
+        <p:txBody>
+          <a:bodyPr wrap="square" lIns="0" tIns="0" rIns="0" bIns="0" rtlCol="0" anchor="ctr"/>
+          <a:lstStyle/>
+          <a:p>
+            <a:pPr indent="0" marL="0">
+              <a:buNone/>
+            </a:pPr>
+            <a:r>
+              <a:rPr lang="en-US" sz="1000" dirty="0">
                 <a:solidFill>
                   <a:srgbClr val="F8FAFC"/>
                 </a:solidFill>
@@ -7963,7 +8256,7 @@
               </a:rPr>
               <a:t>Drafts the full memorandum in structured sections</a:t>
             </a:r>
-            <a:endParaRPr lang="en-US" sz="1050" dirty="0"/>
+            <a:endParaRPr lang="en-US" sz="1000" dirty="0"/>
           </a:p>
         </p:txBody>
       </p:sp>
@@ -7975,24 +8268,24 @@
         </p:nvSpPr>
         <p:spPr>
           <a:xfrm>
-            <a:off x="6236208" y="1380744"/>
-            <a:ext cx="2423160" cy="512064"/>
-          </a:xfrm>
-          <a:prstGeom prst="rect">
-            <a:avLst/>
-          </a:prstGeom>
-          <a:noFill/>
-          <a:ln/>
-        </p:spPr>
-        <p:txBody>
-          <a:bodyPr wrap="square" lIns="0" tIns="0" rIns="0" bIns="0" rtlCol="0" anchor="ctr"/>
-          <a:lstStyle/>
-          <a:p>
-            <a:pPr indent="0" marL="0">
-              <a:buNone/>
-            </a:pPr>
-            <a:r>
-              <a:rPr lang="en-US" sz="1000" dirty="0">
+            <a:off x="6236208" y="1408176"/>
+            <a:ext cx="2423160" cy="493776"/>
+          </a:xfrm>
+          <a:prstGeom prst="rect">
+            <a:avLst/>
+          </a:prstGeom>
+          <a:noFill/>
+          <a:ln/>
+        </p:spPr>
+        <p:txBody>
+          <a:bodyPr wrap="square" lIns="0" tIns="0" rIns="0" bIns="0" rtlCol="0" anchor="ctr"/>
+          <a:lstStyle/>
+          <a:p>
+            <a:pPr indent="0" marL="0">
+              <a:buNone/>
+            </a:pPr>
+            <a:r>
+              <a:rPr lang="en-US" sz="950" dirty="0">
                 <a:solidFill>
                   <a:srgbClr val="CADCFC"/>
                 </a:solidFill>
@@ -8002,7 +8295,7 @@
               </a:rPr>
               <a:t>Metrics, scenarios, risk register, archetype KPIs</a:t>
             </a:r>
-            <a:endParaRPr lang="en-US" sz="1000" dirty="0"/>
+            <a:endParaRPr lang="en-US" sz="950" dirty="0"/>
           </a:p>
         </p:txBody>
       </p:sp>
@@ -8014,24 +8307,24 @@
         </p:nvSpPr>
         <p:spPr>
           <a:xfrm>
-            <a:off x="8961120" y="1380744"/>
-            <a:ext cx="2468880" cy="512064"/>
-          </a:xfrm>
-          <a:prstGeom prst="rect">
-            <a:avLst/>
-          </a:prstGeom>
-          <a:noFill/>
-          <a:ln/>
-        </p:spPr>
-        <p:txBody>
-          <a:bodyPr wrap="square" lIns="0" tIns="0" rIns="0" bIns="0" rtlCol="0" anchor="ctr"/>
-          <a:lstStyle/>
-          <a:p>
-            <a:pPr indent="0" marL="0">
-              <a:buNone/>
-            </a:pPr>
-            <a:r>
-              <a:rPr lang="en-US" sz="1000" i="1" dirty="0">
+            <a:off x="8961120" y="1408176"/>
+            <a:ext cx="2468880" cy="493776"/>
+          </a:xfrm>
+          <a:prstGeom prst="rect">
+            <a:avLst/>
+          </a:prstGeom>
+          <a:noFill/>
+          <a:ln/>
+        </p:spPr>
+        <p:txBody>
+          <a:bodyPr wrap="square" lIns="0" tIns="0" rIns="0" bIns="0" rtlCol="0" anchor="ctr"/>
+          <a:lstStyle/>
+          <a:p>
+            <a:pPr indent="0" marL="0">
+              <a:buNone/>
+            </a:pPr>
+            <a:r>
+              <a:rPr lang="en-US" sz="950" i="1" dirty="0">
                 <a:solidFill>
                   <a:srgbClr val="94A3B8"/>
                 </a:solidFill>
@@ -8041,7 +8334,7 @@
               </a:rPr>
               <a:t>Fluent prose lends false authority to weak assumptions</a:t>
             </a:r>
-            <a:endParaRPr lang="en-US" sz="1000" dirty="0"/>
+            <a:endParaRPr lang="en-US" sz="950" dirty="0"/>
           </a:p>
         </p:txBody>
       </p:sp>
@@ -8053,12 +8346,12 @@
         </p:nvSpPr>
         <p:spPr>
           <a:xfrm>
-            <a:off x="566928" y="2048256"/>
-            <a:ext cx="11057839" cy="621792"/>
+            <a:off x="566928" y="2029968"/>
+            <a:ext cx="11057839" cy="566928"/>
           </a:xfrm>
           <a:prstGeom prst="roundRect">
             <a:avLst>
-              <a:gd name="adj" fmla="val 14706"/>
+              <a:gd name="adj" fmla="val 16129"/>
             </a:avLst>
           </a:prstGeom>
           <a:solidFill>
@@ -8087,7 +8380,7 @@
         </p:nvSpPr>
         <p:spPr>
           <a:xfrm>
-            <a:off x="768096" y="2194560"/>
+            <a:off x="768096" y="2157984"/>
             <a:ext cx="310896" cy="310896"/>
           </a:xfrm>
           <a:prstGeom prst="ellipse">
@@ -8112,7 +8405,7 @@
         </p:nvSpPr>
         <p:spPr>
           <a:xfrm>
-            <a:off x="768096" y="2194560"/>
+            <a:off x="768096" y="2157984"/>
             <a:ext cx="310896" cy="310896"/>
           </a:xfrm>
           <a:prstGeom prst="rect">
@@ -8137,7 +8430,7 @@
                 <a:ea typeface="Calibri" pitchFamily="34" charset="-122"/>
                 <a:cs typeface="Calibri" pitchFamily="34" charset="-120"/>
               </a:rPr>
-              <a:t>7</a:t>
+              <a:t>8</a:t>
             </a:r>
             <a:endParaRPr lang="en-US" sz="1300" dirty="0"/>
           </a:p>
@@ -8151,24 +8444,24 @@
         </p:nvSpPr>
         <p:spPr>
           <a:xfrm>
-            <a:off x="1188720" y="2093976"/>
-            <a:ext cx="2011680" cy="512064"/>
-          </a:xfrm>
-          <a:prstGeom prst="rect">
-            <a:avLst/>
-          </a:prstGeom>
-          <a:noFill/>
-          <a:ln/>
-        </p:spPr>
-        <p:txBody>
-          <a:bodyPr wrap="square" lIns="0" tIns="0" rIns="0" bIns="0" rtlCol="0" anchor="ctr"/>
-          <a:lstStyle/>
-          <a:p>
-            <a:pPr indent="0" marL="0">
-              <a:buNone/>
-            </a:pPr>
-            <a:r>
-              <a:rPr lang="en-US" sz="1200" b="1" dirty="0">
+            <a:off x="1188720" y="2066544"/>
+            <a:ext cx="2011680" cy="493776"/>
+          </a:xfrm>
+          <a:prstGeom prst="rect">
+            <a:avLst/>
+          </a:prstGeom>
+          <a:noFill/>
+          <a:ln/>
+        </p:spPr>
+        <p:txBody>
+          <a:bodyPr wrap="square" lIns="0" tIns="0" rIns="0" bIns="0" rtlCol="0" anchor="ctr"/>
+          <a:lstStyle/>
+          <a:p>
+            <a:pPr indent="0" marL="0">
+              <a:buNone/>
+            </a:pPr>
+            <a:r>
+              <a:rPr lang="en-US" sz="1150" b="1" dirty="0">
                 <a:solidFill>
                   <a:srgbClr val="22D3EE"/>
                 </a:solidFill>
@@ -8178,7 +8471,7 @@
               </a:rPr>
               <a:t>Scenario studio</a:t>
             </a:r>
-            <a:endParaRPr lang="en-US" sz="1200" dirty="0"/>
+            <a:endParaRPr lang="en-US" sz="1150" dirty="0"/>
           </a:p>
         </p:txBody>
       </p:sp>
@@ -8190,24 +8483,24 @@
         </p:nvSpPr>
         <p:spPr>
           <a:xfrm>
-            <a:off x="3236976" y="2093976"/>
-            <a:ext cx="2697480" cy="512064"/>
-          </a:xfrm>
-          <a:prstGeom prst="rect">
-            <a:avLst/>
-          </a:prstGeom>
-          <a:noFill/>
-          <a:ln/>
-        </p:spPr>
-        <p:txBody>
-          <a:bodyPr wrap="square" lIns="0" tIns="0" rIns="0" bIns="0" rtlCol="0" anchor="ctr"/>
-          <a:lstStyle/>
-          <a:p>
-            <a:pPr indent="0" marL="0">
-              <a:buNone/>
-            </a:pPr>
-            <a:r>
-              <a:rPr lang="en-US" sz="1050" dirty="0">
+            <a:off x="3236976" y="2066544"/>
+            <a:ext cx="2697480" cy="493776"/>
+          </a:xfrm>
+          <a:prstGeom prst="rect">
+            <a:avLst/>
+          </a:prstGeom>
+          <a:noFill/>
+          <a:ln/>
+        </p:spPr>
+        <p:txBody>
+          <a:bodyPr wrap="square" lIns="0" tIns="0" rIns="0" bIns="0" rtlCol="0" anchor="ctr"/>
+          <a:lstStyle/>
+          <a:p>
+            <a:pPr indent="0" marL="0">
+              <a:buNone/>
+            </a:pPr>
+            <a:r>
+              <a:rPr lang="en-US" sz="1000" dirty="0">
                 <a:solidFill>
                   <a:srgbClr val="F8FAFC"/>
                 </a:solidFill>
@@ -8217,7 +8510,7 @@
               </a:rPr>
               <a:t>Proposes named scenarios beyond the standard three</a:t>
             </a:r>
-            <a:endParaRPr lang="en-US" sz="1050" dirty="0"/>
+            <a:endParaRPr lang="en-US" sz="1000" dirty="0"/>
           </a:p>
         </p:txBody>
       </p:sp>
@@ -8229,24 +8522,24 @@
         </p:nvSpPr>
         <p:spPr>
           <a:xfrm>
-            <a:off x="6236208" y="2093976"/>
-            <a:ext cx="2423160" cy="512064"/>
-          </a:xfrm>
-          <a:prstGeom prst="rect">
-            <a:avLst/>
-          </a:prstGeom>
-          <a:noFill/>
-          <a:ln/>
-        </p:spPr>
-        <p:txBody>
-          <a:bodyPr wrap="square" lIns="0" tIns="0" rIns="0" bIns="0" rtlCol="0" anchor="ctr"/>
-          <a:lstStyle/>
-          <a:p>
-            <a:pPr indent="0" marL="0">
-              <a:buNone/>
-            </a:pPr>
-            <a:r>
-              <a:rPr lang="en-US" sz="1000" dirty="0">
+            <a:off x="6236208" y="2066544"/>
+            <a:ext cx="2423160" cy="493776"/>
+          </a:xfrm>
+          <a:prstGeom prst="rect">
+            <a:avLst/>
+          </a:prstGeom>
+          <a:noFill/>
+          <a:ln/>
+        </p:spPr>
+        <p:txBody>
+          <a:bodyPr wrap="square" lIns="0" tIns="0" rIns="0" bIns="0" rtlCol="0" anchor="ctr"/>
+          <a:lstStyle/>
+          <a:p>
+            <a:pPr indent="0" marL="0">
+              <a:buNone/>
+            </a:pPr>
+            <a:r>
+              <a:rPr lang="en-US" sz="950" dirty="0">
                 <a:solidFill>
                   <a:srgbClr val="CADCFC"/>
                 </a:solidFill>
@@ -8256,7 +8549,7 @@
               </a:rPr>
               <a:t>Archetype scenario themes and base-case posture</a:t>
             </a:r>
-            <a:endParaRPr lang="en-US" sz="1000" dirty="0"/>
+            <a:endParaRPr lang="en-US" sz="950" dirty="0"/>
           </a:p>
         </p:txBody>
       </p:sp>
@@ -8268,24 +8561,24 @@
         </p:nvSpPr>
         <p:spPr>
           <a:xfrm>
-            <a:off x="8961120" y="2093976"/>
-            <a:ext cx="2468880" cy="512064"/>
-          </a:xfrm>
-          <a:prstGeom prst="rect">
-            <a:avLst/>
-          </a:prstGeom>
-          <a:noFill/>
-          <a:ln/>
-        </p:spPr>
-        <p:txBody>
-          <a:bodyPr wrap="square" lIns="0" tIns="0" rIns="0" bIns="0" rtlCol="0" anchor="ctr"/>
-          <a:lstStyle/>
-          <a:p>
-            <a:pPr indent="0" marL="0">
-              <a:buNone/>
-            </a:pPr>
-            <a:r>
-              <a:rPr lang="en-US" sz="1000" i="1" dirty="0">
+            <a:off x="8961120" y="2066544"/>
+            <a:ext cx="2468880" cy="493776"/>
+          </a:xfrm>
+          <a:prstGeom prst="rect">
+            <a:avLst/>
+          </a:prstGeom>
+          <a:noFill/>
+          <a:ln/>
+        </p:spPr>
+        <p:txBody>
+          <a:bodyPr wrap="square" lIns="0" tIns="0" rIns="0" bIns="0" rtlCol="0" anchor="ctr"/>
+          <a:lstStyle/>
+          <a:p>
+            <a:pPr indent="0" marL="0">
+              <a:buNone/>
+            </a:pPr>
+            <a:r>
+              <a:rPr lang="en-US" sz="950" i="1" dirty="0">
                 <a:solidFill>
                   <a:srgbClr val="94A3B8"/>
                 </a:solidFill>
@@ -8295,7 +8588,7 @@
               </a:rPr>
               <a:t>Proposes assumptions only — it never produces results</a:t>
             </a:r>
-            <a:endParaRPr lang="en-US" sz="1000" dirty="0"/>
+            <a:endParaRPr lang="en-US" sz="950" dirty="0"/>
           </a:p>
         </p:txBody>
       </p:sp>
@@ -8307,12 +8600,12 @@
         </p:nvSpPr>
         <p:spPr>
           <a:xfrm>
-            <a:off x="566928" y="2761488"/>
-            <a:ext cx="11057839" cy="621792"/>
+            <a:off x="566928" y="2688336"/>
+            <a:ext cx="11057839" cy="566928"/>
           </a:xfrm>
           <a:prstGeom prst="roundRect">
             <a:avLst>
-              <a:gd name="adj" fmla="val 14706"/>
+              <a:gd name="adj" fmla="val 16129"/>
             </a:avLst>
           </a:prstGeom>
           <a:solidFill>
@@ -8341,7 +8634,7 @@
         </p:nvSpPr>
         <p:spPr>
           <a:xfrm>
-            <a:off x="768096" y="2907792"/>
+            <a:off x="768096" y="2816352"/>
             <a:ext cx="310896" cy="310896"/>
           </a:xfrm>
           <a:prstGeom prst="ellipse">
@@ -8366,7 +8659,7 @@
         </p:nvSpPr>
         <p:spPr>
           <a:xfrm>
-            <a:off x="768096" y="2907792"/>
+            <a:off x="768096" y="2816352"/>
             <a:ext cx="310896" cy="310896"/>
           </a:xfrm>
           <a:prstGeom prst="rect">
@@ -8391,7 +8684,7 @@
                 <a:ea typeface="Calibri" pitchFamily="34" charset="-122"/>
                 <a:cs typeface="Calibri" pitchFamily="34" charset="-120"/>
               </a:rPr>
-              <a:t>8</a:t>
+              <a:t>9</a:t>
             </a:r>
             <a:endParaRPr lang="en-US" sz="1300" dirty="0"/>
           </a:p>
@@ -8405,24 +8698,24 @@
         </p:nvSpPr>
         <p:spPr>
           <a:xfrm>
-            <a:off x="1188720" y="2807208"/>
-            <a:ext cx="2011680" cy="512064"/>
-          </a:xfrm>
-          <a:prstGeom prst="rect">
-            <a:avLst/>
-          </a:prstGeom>
-          <a:noFill/>
-          <a:ln/>
-        </p:spPr>
-        <p:txBody>
-          <a:bodyPr wrap="square" lIns="0" tIns="0" rIns="0" bIns="0" rtlCol="0" anchor="ctr"/>
-          <a:lstStyle/>
-          <a:p>
-            <a:pPr indent="0" marL="0">
-              <a:buNone/>
-            </a:pPr>
-            <a:r>
-              <a:rPr lang="en-US" sz="1200" b="1" dirty="0">
+            <a:off x="1188720" y="2724912"/>
+            <a:ext cx="2011680" cy="493776"/>
+          </a:xfrm>
+          <a:prstGeom prst="rect">
+            <a:avLst/>
+          </a:prstGeom>
+          <a:noFill/>
+          <a:ln/>
+        </p:spPr>
+        <p:txBody>
+          <a:bodyPr wrap="square" lIns="0" tIns="0" rIns="0" bIns="0" rtlCol="0" anchor="ctr"/>
+          <a:lstStyle/>
+          <a:p>
+            <a:pPr indent="0" marL="0">
+              <a:buNone/>
+            </a:pPr>
+            <a:r>
+              <a:rPr lang="en-US" sz="1150" b="1" dirty="0">
                 <a:solidFill>
                   <a:srgbClr val="22D3EE"/>
                 </a:solidFill>
@@ -8432,7 +8725,7 @@
               </a:rPr>
               <a:t>ESG impact</a:t>
             </a:r>
-            <a:endParaRPr lang="en-US" sz="1200" dirty="0"/>
+            <a:endParaRPr lang="en-US" sz="1150" dirty="0"/>
           </a:p>
         </p:txBody>
       </p:sp>
@@ -8444,24 +8737,24 @@
         </p:nvSpPr>
         <p:spPr>
           <a:xfrm>
-            <a:off x="3236976" y="2807208"/>
-            <a:ext cx="2697480" cy="512064"/>
-          </a:xfrm>
-          <a:prstGeom prst="rect">
-            <a:avLst/>
-          </a:prstGeom>
-          <a:noFill/>
-          <a:ln/>
-        </p:spPr>
-        <p:txBody>
-          <a:bodyPr wrap="square" lIns="0" tIns="0" rIns="0" bIns="0" rtlCol="0" anchor="ctr"/>
-          <a:lstStyle/>
-          <a:p>
-            <a:pPr indent="0" marL="0">
-              <a:buNone/>
-            </a:pPr>
-            <a:r>
-              <a:rPr lang="en-US" sz="1050" dirty="0">
+            <a:off x="3236976" y="2724912"/>
+            <a:ext cx="2697480" cy="493776"/>
+          </a:xfrm>
+          <a:prstGeom prst="rect">
+            <a:avLst/>
+          </a:prstGeom>
+          <a:noFill/>
+          <a:ln/>
+        </p:spPr>
+        <p:txBody>
+          <a:bodyPr wrap="square" lIns="0" tIns="0" rIns="0" bIns="0" rtlCol="0" anchor="ctr"/>
+          <a:lstStyle/>
+          <a:p>
+            <a:pPr indent="0" marL="0">
+              <a:buNone/>
+            </a:pPr>
+            <a:r>
+              <a:rPr lang="en-US" sz="1000" dirty="0">
                 <a:solidFill>
                   <a:srgbClr val="F8FAFC"/>
                 </a:solidFill>
@@ -8471,7 +8764,7 @@
               </a:rPr>
               <a:t>Green-financing commentary, or an explicit not-applicable flag</a:t>
             </a:r>
-            <a:endParaRPr lang="en-US" sz="1050" dirty="0"/>
+            <a:endParaRPr lang="en-US" sz="1000" dirty="0"/>
           </a:p>
         </p:txBody>
       </p:sp>
@@ -8483,24 +8776,24 @@
         </p:nvSpPr>
         <p:spPr>
           <a:xfrm>
-            <a:off x="6236208" y="2807208"/>
-            <a:ext cx="2423160" cy="512064"/>
-          </a:xfrm>
-          <a:prstGeom prst="rect">
-            <a:avLst/>
-          </a:prstGeom>
-          <a:noFill/>
-          <a:ln/>
-        </p:spPr>
-        <p:txBody>
-          <a:bodyPr wrap="square" lIns="0" tIns="0" rIns="0" bIns="0" rtlCol="0" anchor="ctr"/>
-          <a:lstStyle/>
-          <a:p>
-            <a:pPr indent="0" marL="0">
-              <a:buNone/>
-            </a:pPr>
-            <a:r>
-              <a:rPr lang="en-US" sz="1000" dirty="0">
+            <a:off x="6236208" y="2724912"/>
+            <a:ext cx="2423160" cy="493776"/>
+          </a:xfrm>
+          <a:prstGeom prst="rect">
+            <a:avLst/>
+          </a:prstGeom>
+          <a:noFill/>
+          <a:ln/>
+        </p:spPr>
+        <p:txBody>
+          <a:bodyPr wrap="square" lIns="0" tIns="0" rIns="0" bIns="0" rtlCol="0" anchor="ctr"/>
+          <a:lstStyle/>
+          <a:p>
+            <a:pPr indent="0" marL="0">
+              <a:buNone/>
+            </a:pPr>
+            <a:r>
+              <a:rPr lang="en-US" sz="950" dirty="0">
                 <a:solidFill>
                   <a:srgbClr val="CADCFC"/>
                 </a:solidFill>
@@ -8510,7 +8803,7 @@
               </a:rPr>
               <a:t>Capex composition and archetype relevance</a:t>
             </a:r>
-            <a:endParaRPr lang="en-US" sz="1000" dirty="0"/>
+            <a:endParaRPr lang="en-US" sz="950" dirty="0"/>
           </a:p>
         </p:txBody>
       </p:sp>
@@ -8522,24 +8815,24 @@
         </p:nvSpPr>
         <p:spPr>
           <a:xfrm>
-            <a:off x="8961120" y="2807208"/>
-            <a:ext cx="2468880" cy="512064"/>
-          </a:xfrm>
-          <a:prstGeom prst="rect">
-            <a:avLst/>
-          </a:prstGeom>
-          <a:noFill/>
-          <a:ln/>
-        </p:spPr>
-        <p:txBody>
-          <a:bodyPr wrap="square" lIns="0" tIns="0" rIns="0" bIns="0" rtlCol="0" anchor="ctr"/>
-          <a:lstStyle/>
-          <a:p>
-            <a:pPr indent="0" marL="0">
-              <a:buNone/>
-            </a:pPr>
-            <a:r>
-              <a:rPr lang="en-US" sz="1000" i="1" dirty="0">
+            <a:off x="8961120" y="2724912"/>
+            <a:ext cx="2468880" cy="493776"/>
+          </a:xfrm>
+          <a:prstGeom prst="rect">
+            <a:avLst/>
+          </a:prstGeom>
+          <a:noFill/>
+          <a:ln/>
+        </p:spPr>
+        <p:txBody>
+          <a:bodyPr wrap="square" lIns="0" tIns="0" rIns="0" bIns="0" rtlCol="0" anchor="ctr"/>
+          <a:lstStyle/>
+          <a:p>
+            <a:pPr indent="0" marL="0">
+              <a:buNone/>
+            </a:pPr>
+            <a:r>
+              <a:rPr lang="en-US" sz="950" i="1" dirty="0">
                 <a:solidFill>
                   <a:srgbClr val="94A3B8"/>
                 </a:solidFill>
@@ -8549,7 +8842,7 @@
               </a:rPr>
               <a:t>Not an assurance opinion and no substitute for one</a:t>
             </a:r>
-            <a:endParaRPr lang="en-US" sz="1000" dirty="0"/>
+            <a:endParaRPr lang="en-US" sz="950" dirty="0"/>
           </a:p>
         </p:txBody>
       </p:sp>
@@ -8561,12 +8854,12 @@
         </p:nvSpPr>
         <p:spPr>
           <a:xfrm>
-            <a:off x="566928" y="3474720"/>
-            <a:ext cx="11057839" cy="621792"/>
+            <a:off x="566928" y="3346704"/>
+            <a:ext cx="11057839" cy="566928"/>
           </a:xfrm>
           <a:prstGeom prst="roundRect">
             <a:avLst>
-              <a:gd name="adj" fmla="val 14706"/>
+              <a:gd name="adj" fmla="val 16129"/>
             </a:avLst>
           </a:prstGeom>
           <a:solidFill>
@@ -8595,7 +8888,7 @@
         </p:nvSpPr>
         <p:spPr>
           <a:xfrm>
-            <a:off x="768096" y="3621024"/>
+            <a:off x="768096" y="3474720"/>
             <a:ext cx="310896" cy="310896"/>
           </a:xfrm>
           <a:prstGeom prst="ellipse">
@@ -8620,7 +8913,7 @@
         </p:nvSpPr>
         <p:spPr>
           <a:xfrm>
-            <a:off x="768096" y="3621024"/>
+            <a:off x="768096" y="3474720"/>
             <a:ext cx="310896" cy="310896"/>
           </a:xfrm>
           <a:prstGeom prst="rect">
@@ -8645,7 +8938,7 @@
                 <a:ea typeface="Calibri" pitchFamily="34" charset="-122"/>
                 <a:cs typeface="Calibri" pitchFamily="34" charset="-120"/>
               </a:rPr>
-              <a:t>9</a:t>
+              <a:t>10</a:t>
             </a:r>
             <a:endParaRPr lang="en-US" sz="1300" dirty="0"/>
           </a:p>
@@ -8659,24 +8952,24 @@
         </p:nvSpPr>
         <p:spPr>
           <a:xfrm>
-            <a:off x="1188720" y="3520440"/>
-            <a:ext cx="2011680" cy="512064"/>
-          </a:xfrm>
-          <a:prstGeom prst="rect">
-            <a:avLst/>
-          </a:prstGeom>
-          <a:noFill/>
-          <a:ln/>
-        </p:spPr>
-        <p:txBody>
-          <a:bodyPr wrap="square" lIns="0" tIns="0" rIns="0" bIns="0" rtlCol="0" anchor="ctr"/>
-          <a:lstStyle/>
-          <a:p>
-            <a:pPr indent="0" marL="0">
-              <a:buNone/>
-            </a:pPr>
-            <a:r>
-              <a:rPr lang="en-US" sz="1200" b="1" dirty="0">
+            <a:off x="1188720" y="3383280"/>
+            <a:ext cx="2011680" cy="493776"/>
+          </a:xfrm>
+          <a:prstGeom prst="rect">
+            <a:avLst/>
+          </a:prstGeom>
+          <a:noFill/>
+          <a:ln/>
+        </p:spPr>
+        <p:txBody>
+          <a:bodyPr wrap="square" lIns="0" tIns="0" rIns="0" bIns="0" rtlCol="0" anchor="ctr"/>
+          <a:lstStyle/>
+          <a:p>
+            <a:pPr indent="0" marL="0">
+              <a:buNone/>
+            </a:pPr>
+            <a:r>
+              <a:rPr lang="en-US" sz="1150" b="1" dirty="0">
                 <a:solidFill>
                   <a:srgbClr val="22D3EE"/>
                 </a:solidFill>
@@ -8686,7 +8979,7 @@
               </a:rPr>
               <a:t>Quote parser</a:t>
             </a:r>
-            <a:endParaRPr lang="en-US" sz="1200" dirty="0"/>
+            <a:endParaRPr lang="en-US" sz="1150" dirty="0"/>
           </a:p>
         </p:txBody>
       </p:sp>
@@ -8698,24 +8991,24 @@
         </p:nvSpPr>
         <p:spPr>
           <a:xfrm>
-            <a:off x="3236976" y="3520440"/>
-            <a:ext cx="2697480" cy="512064"/>
-          </a:xfrm>
-          <a:prstGeom prst="rect">
-            <a:avLst/>
-          </a:prstGeom>
-          <a:noFill/>
-          <a:ln/>
-        </p:spPr>
-        <p:txBody>
-          <a:bodyPr wrap="square" lIns="0" tIns="0" rIns="0" bIns="0" rtlCol="0" anchor="ctr"/>
-          <a:lstStyle/>
-          <a:p>
-            <a:pPr indent="0" marL="0">
-              <a:buNone/>
-            </a:pPr>
-            <a:r>
-              <a:rPr lang="en-US" sz="1050" dirty="0">
+            <a:off x="3236976" y="3383280"/>
+            <a:ext cx="2697480" cy="493776"/>
+          </a:xfrm>
+          <a:prstGeom prst="rect">
+            <a:avLst/>
+          </a:prstGeom>
+          <a:noFill/>
+          <a:ln/>
+        </p:spPr>
+        <p:txBody>
+          <a:bodyPr wrap="square" lIns="0" tIns="0" rIns="0" bIns="0" rtlCol="0" anchor="ctr"/>
+          <a:lstStyle/>
+          <a:p>
+            <a:pPr indent="0" marL="0">
+              <a:buNone/>
+            </a:pPr>
+            <a:r>
+              <a:rPr lang="en-US" sz="1000" dirty="0">
                 <a:solidFill>
                   <a:srgbClr val="F8FAFC"/>
                 </a:solidFill>
@@ -8725,7 +9018,7 @@
               </a:rPr>
               <a:t>Extracts structured capex lines from pasted vendor quotations</a:t>
             </a:r>
-            <a:endParaRPr lang="en-US" sz="1050" dirty="0"/>
+            <a:endParaRPr lang="en-US" sz="1000" dirty="0"/>
           </a:p>
         </p:txBody>
       </p:sp>
@@ -8737,24 +9030,24 @@
         </p:nvSpPr>
         <p:spPr>
           <a:xfrm>
-            <a:off x="6236208" y="3520440"/>
-            <a:ext cx="2423160" cy="512064"/>
-          </a:xfrm>
-          <a:prstGeom prst="rect">
-            <a:avLst/>
-          </a:prstGeom>
-          <a:noFill/>
-          <a:ln/>
-        </p:spPr>
-        <p:txBody>
-          <a:bodyPr wrap="square" lIns="0" tIns="0" rIns="0" bIns="0" rtlCol="0" anchor="ctr"/>
-          <a:lstStyle/>
-          <a:p>
-            <a:pPr indent="0" marL="0">
-              <a:buNone/>
-            </a:pPr>
-            <a:r>
-              <a:rPr lang="en-US" sz="1000" dirty="0">
+            <a:off x="6236208" y="3383280"/>
+            <a:ext cx="2423160" cy="493776"/>
+          </a:xfrm>
+          <a:prstGeom prst="rect">
+            <a:avLst/>
+          </a:prstGeom>
+          <a:noFill/>
+          <a:ln/>
+        </p:spPr>
+        <p:txBody>
+          <a:bodyPr wrap="square" lIns="0" tIns="0" rIns="0" bIns="0" rtlCol="0" anchor="ctr"/>
+          <a:lstStyle/>
+          <a:p>
+            <a:pPr indent="0" marL="0">
+              <a:buNone/>
+            </a:pPr>
+            <a:r>
+              <a:rPr lang="en-US" sz="950" dirty="0">
                 <a:solidFill>
                   <a:srgbClr val="CADCFC"/>
                 </a:solidFill>
@@ -8764,7 +9057,7 @@
               </a:rPr>
               <a:t>Raw quotation text, archetype capex categories</a:t>
             </a:r>
-            <a:endParaRPr lang="en-US" sz="1000" dirty="0"/>
+            <a:endParaRPr lang="en-US" sz="950" dirty="0"/>
           </a:p>
         </p:txBody>
       </p:sp>
@@ -8776,24 +9069,24 @@
         </p:nvSpPr>
         <p:spPr>
           <a:xfrm>
-            <a:off x="8961120" y="3520440"/>
-            <a:ext cx="2468880" cy="512064"/>
-          </a:xfrm>
-          <a:prstGeom prst="rect">
-            <a:avLst/>
-          </a:prstGeom>
-          <a:noFill/>
-          <a:ln/>
-        </p:spPr>
-        <p:txBody>
-          <a:bodyPr wrap="square" lIns="0" tIns="0" rIns="0" bIns="0" rtlCol="0" anchor="ctr"/>
-          <a:lstStyle/>
-          <a:p>
-            <a:pPr indent="0" marL="0">
-              <a:buNone/>
-            </a:pPr>
-            <a:r>
-              <a:rPr lang="en-US" sz="1000" i="1" dirty="0">
+            <a:off x="8961120" y="3383280"/>
+            <a:ext cx="2468880" cy="493776"/>
+          </a:xfrm>
+          <a:prstGeom prst="rect">
+            <a:avLst/>
+          </a:prstGeom>
+          <a:noFill/>
+          <a:ln/>
+        </p:spPr>
+        <p:txBody>
+          <a:bodyPr wrap="square" lIns="0" tIns="0" rIns="0" bIns="0" rtlCol="0" anchor="ctr"/>
+          <a:lstStyle/>
+          <a:p>
+            <a:pPr indent="0" marL="0">
+              <a:buNone/>
+            </a:pPr>
+            <a:r>
+              <a:rPr lang="en-US" sz="950" i="1" dirty="0">
                 <a:solidFill>
                   <a:srgbClr val="94A3B8"/>
                 </a:solidFill>
@@ -8803,7 +9096,7 @@
               </a:rPr>
               <a:t>Ambiguous lines returned unparsed rather than guessed</a:t>
             </a:r>
-            <a:endParaRPr lang="en-US" sz="1000" dirty="0"/>
+            <a:endParaRPr lang="en-US" sz="950" dirty="0"/>
           </a:p>
         </p:txBody>
       </p:sp>
@@ -8815,12 +9108,12 @@
         </p:nvSpPr>
         <p:spPr>
           <a:xfrm>
-            <a:off x="566928" y="4187952"/>
-            <a:ext cx="11057839" cy="621792"/>
+            <a:off x="566928" y="4005072"/>
+            <a:ext cx="11057839" cy="566928"/>
           </a:xfrm>
           <a:prstGeom prst="roundRect">
             <a:avLst>
-              <a:gd name="adj" fmla="val 14706"/>
+              <a:gd name="adj" fmla="val 16129"/>
             </a:avLst>
           </a:prstGeom>
           <a:solidFill>
@@ -8849,7 +9142,7 @@
         </p:nvSpPr>
         <p:spPr>
           <a:xfrm>
-            <a:off x="768096" y="4334256"/>
+            <a:off x="768096" y="4133088"/>
             <a:ext cx="310896" cy="310896"/>
           </a:xfrm>
           <a:prstGeom prst="ellipse">
@@ -8874,7 +9167,7 @@
         </p:nvSpPr>
         <p:spPr>
           <a:xfrm>
-            <a:off x="768096" y="4334256"/>
+            <a:off x="768096" y="4133088"/>
             <a:ext cx="310896" cy="310896"/>
           </a:xfrm>
           <a:prstGeom prst="rect">
@@ -8899,7 +9192,7 @@
                 <a:ea typeface="Calibri" pitchFamily="34" charset="-122"/>
                 <a:cs typeface="Calibri" pitchFamily="34" charset="-120"/>
               </a:rPr>
-              <a:t>10</a:t>
+              <a:t>11</a:t>
             </a:r>
             <a:endParaRPr lang="en-US" sz="1300" dirty="0"/>
           </a:p>
@@ -8913,24 +9206,24 @@
         </p:nvSpPr>
         <p:spPr>
           <a:xfrm>
-            <a:off x="1188720" y="4233672"/>
-            <a:ext cx="2011680" cy="512064"/>
-          </a:xfrm>
-          <a:prstGeom prst="rect">
-            <a:avLst/>
-          </a:prstGeom>
-          <a:noFill/>
-          <a:ln/>
-        </p:spPr>
-        <p:txBody>
-          <a:bodyPr wrap="square" lIns="0" tIns="0" rIns="0" bIns="0" rtlCol="0" anchor="ctr"/>
-          <a:lstStyle/>
-          <a:p>
-            <a:pPr indent="0" marL="0">
-              <a:buNone/>
-            </a:pPr>
-            <a:r>
-              <a:rPr lang="en-US" sz="1200" b="1" dirty="0">
+            <a:off x="1188720" y="4041648"/>
+            <a:ext cx="2011680" cy="493776"/>
+          </a:xfrm>
+          <a:prstGeom prst="rect">
+            <a:avLst/>
+          </a:prstGeom>
+          <a:noFill/>
+          <a:ln/>
+        </p:spPr>
+        <p:txBody>
+          <a:bodyPr wrap="square" lIns="0" tIns="0" rIns="0" bIns="0" rtlCol="0" anchor="ctr"/>
+          <a:lstStyle/>
+          <a:p>
+            <a:pPr indent="0" marL="0">
+              <a:buNone/>
+            </a:pPr>
+            <a:r>
+              <a:rPr lang="en-US" sz="1150" b="1" dirty="0">
                 <a:solidFill>
                   <a:srgbClr val="22D3EE"/>
                 </a:solidFill>
@@ -8938,9 +9231,9 @@
                 <a:ea typeface="Calibri" pitchFamily="34" charset="-122"/>
                 <a:cs typeface="Calibri" pitchFamily="34" charset="-120"/>
               </a:rPr>
-              <a:t>Macro briefing</a:t>
-            </a:r>
-            <a:endParaRPr lang="en-US" sz="1200" dirty="0"/>
+              <a:t>Macro reference</a:t>
+            </a:r>
+            <a:endParaRPr lang="en-US" sz="1150" dirty="0"/>
           </a:p>
         </p:txBody>
       </p:sp>
@@ -8952,24 +9245,24 @@
         </p:nvSpPr>
         <p:spPr>
           <a:xfrm>
-            <a:off x="3236976" y="4233672"/>
-            <a:ext cx="2697480" cy="512064"/>
-          </a:xfrm>
-          <a:prstGeom prst="rect">
-            <a:avLst/>
-          </a:prstGeom>
-          <a:noFill/>
-          <a:ln/>
-        </p:spPr>
-        <p:txBody>
-          <a:bodyPr wrap="square" lIns="0" tIns="0" rIns="0" bIns="0" rtlCol="0" anchor="ctr"/>
-          <a:lstStyle/>
-          <a:p>
-            <a:pPr indent="0" marL="0">
-              <a:buNone/>
-            </a:pPr>
-            <a:r>
-              <a:rPr lang="en-US" sz="1050" dirty="0">
+            <a:off x="3236976" y="4041648"/>
+            <a:ext cx="2697480" cy="493776"/>
+          </a:xfrm>
+          <a:prstGeom prst="rect">
+            <a:avLst/>
+          </a:prstGeom>
+          <a:noFill/>
+          <a:ln/>
+        </p:spPr>
+        <p:txBody>
+          <a:bodyPr wrap="square" lIns="0" tIns="0" rIns="0" bIns="0" rtlCol="0" anchor="ctr"/>
+          <a:lstStyle/>
+          <a:p>
+            <a:pPr indent="0" marL="0">
+              <a:buNone/>
+            </a:pPr>
+            <a:r>
+              <a:rPr lang="en-US" sz="1000" dirty="0">
                 <a:solidFill>
                   <a:srgbClr val="F8FAFC"/>
                 </a:solidFill>
@@ -8977,9 +9270,9 @@
                 <a:ea typeface="Calibri" pitchFamily="34" charset="-122"/>
                 <a:cs typeface="Calibri" pitchFamily="34" charset="-120"/>
               </a:rPr>
-              <a:t>Summarises the macro drivers that matter for this archetype</a:t>
-            </a:r>
-            <a:endParaRPr lang="en-US" sz="1050" dirty="0"/>
+              <a:t>Presents the external rate, tariff and tax basis behind the model</a:t>
+            </a:r>
+            <a:endParaRPr lang="en-US" sz="1000" dirty="0"/>
           </a:p>
         </p:txBody>
       </p:sp>
@@ -8991,24 +9284,24 @@
         </p:nvSpPr>
         <p:spPr>
           <a:xfrm>
-            <a:off x="6236208" y="4233672"/>
-            <a:ext cx="2423160" cy="512064"/>
-          </a:xfrm>
-          <a:prstGeom prst="rect">
-            <a:avLst/>
-          </a:prstGeom>
-          <a:noFill/>
-          <a:ln/>
-        </p:spPr>
-        <p:txBody>
-          <a:bodyPr wrap="square" lIns="0" tIns="0" rIns="0" bIns="0" rtlCol="0" anchor="ctr"/>
-          <a:lstStyle/>
-          <a:p>
-            <a:pPr indent="0" marL="0">
-              <a:buNone/>
-            </a:pPr>
-            <a:r>
-              <a:rPr lang="en-US" sz="1000" dirty="0">
+            <a:off x="6236208" y="4041648"/>
+            <a:ext cx="2423160" cy="493776"/>
+          </a:xfrm>
+          <a:prstGeom prst="rect">
+            <a:avLst/>
+          </a:prstGeom>
+          <a:noFill/>
+          <a:ln/>
+        </p:spPr>
+        <p:txBody>
+          <a:bodyPr wrap="square" lIns="0" tIns="0" rIns="0" bIns="0" rtlCol="0" anchor="ctr"/>
+          <a:lstStyle/>
+          <a:p>
+            <a:pPr indent="0" marL="0">
+              <a:buNone/>
+            </a:pPr>
+            <a:r>
+              <a:rPr lang="en-US" sz="950" dirty="0">
                 <a:solidFill>
                   <a:srgbClr val="CADCFC"/>
                 </a:solidFill>
@@ -9016,9 +9309,9 @@
                 <a:ea typeface="Calibri" pitchFamily="34" charset="-122"/>
                 <a:cs typeface="Calibri" pitchFamily="34" charset="-120"/>
               </a:rPr>
-              <a:t>Rates, FX, tariff and inflation data passed in the request</a:t>
-            </a:r>
-            <a:endParaRPr lang="en-US" sz="1000" dirty="0"/>
+              <a:t>Values transcribed by hand, each with citation and as-of date</a:t>
+            </a:r>
+            <a:endParaRPr lang="en-US" sz="950" dirty="0"/>
           </a:p>
         </p:txBody>
       </p:sp>
@@ -9030,24 +9323,24 @@
         </p:nvSpPr>
         <p:spPr>
           <a:xfrm>
-            <a:off x="8961120" y="4233672"/>
-            <a:ext cx="2468880" cy="512064"/>
-          </a:xfrm>
-          <a:prstGeom prst="rect">
-            <a:avLst/>
-          </a:prstGeom>
-          <a:noFill/>
-          <a:ln/>
-        </p:spPr>
-        <p:txBody>
-          <a:bodyPr wrap="square" lIns="0" tIns="0" rIns="0" bIns="0" rtlCol="0" anchor="ctr"/>
-          <a:lstStyle/>
-          <a:p>
-            <a:pPr indent="0" marL="0">
-              <a:buNone/>
-            </a:pPr>
-            <a:r>
-              <a:rPr lang="en-US" sz="1000" i="1" dirty="0">
+            <a:off x="8961120" y="4041648"/>
+            <a:ext cx="2468880" cy="493776"/>
+          </a:xfrm>
+          <a:prstGeom prst="rect">
+            <a:avLst/>
+          </a:prstGeom>
+          <a:noFill/>
+          <a:ln/>
+        </p:spPr>
+        <p:txBody>
+          <a:bodyPr wrap="square" lIns="0" tIns="0" rIns="0" bIns="0" rtlCol="0" anchor="ctr"/>
+          <a:lstStyle/>
+          <a:p>
+            <a:pPr indent="0" marL="0">
+              <a:buNone/>
+            </a:pPr>
+            <a:r>
+              <a:rPr lang="en-US" sz="950" i="1" dirty="0">
                 <a:solidFill>
                   <a:srgbClr val="94A3B8"/>
                 </a:solidFill>
@@ -9055,9 +9348,9 @@
                 <a:ea typeface="Calibri" pitchFamily="34" charset="-122"/>
                 <a:cs typeface="Calibri" pitchFamily="34" charset="-120"/>
               </a:rPr>
-              <a:t>No live market access — reasons only over supplied data</a:t>
-            </a:r>
-            <a:endParaRPr lang="en-US" sz="1000" dirty="0"/>
+              <a:t>Point-in-time — flagged not live, and re-transcribed as sources change</a:t>
+            </a:r>
+            <a:endParaRPr lang="en-US" sz="950" dirty="0"/>
           </a:p>
         </p:txBody>
       </p:sp>
@@ -9069,12 +9362,12 @@
         </p:nvSpPr>
         <p:spPr>
           <a:xfrm>
-            <a:off x="566928" y="4846320"/>
-            <a:ext cx="5413248" cy="786384"/>
+            <a:off x="566928" y="4663440"/>
+            <a:ext cx="11057839" cy="566928"/>
           </a:xfrm>
           <a:prstGeom prst="roundRect">
             <a:avLst>
-              <a:gd name="adj" fmla="val 11628"/>
+              <a:gd name="adj" fmla="val 16129"/>
             </a:avLst>
           </a:prstGeom>
           <a:solidFill>
@@ -9103,7 +9396,7 @@
         </p:nvSpPr>
         <p:spPr>
           <a:xfrm>
-            <a:off x="786384" y="5029200"/>
+            <a:off x="768096" y="4791456"/>
             <a:ext cx="310896" cy="310896"/>
           </a:xfrm>
           <a:prstGeom prst="ellipse">
@@ -9128,7 +9421,7 @@
         </p:nvSpPr>
         <p:spPr>
           <a:xfrm>
-            <a:off x="786384" y="5029200"/>
+            <a:off x="768096" y="4791456"/>
             <a:ext cx="310896" cy="310896"/>
           </a:xfrm>
           <a:prstGeom prst="rect">
@@ -9153,7 +9446,7 @@
                 <a:ea typeface="Calibri" pitchFamily="34" charset="-122"/>
                 <a:cs typeface="Calibri" pitchFamily="34" charset="-120"/>
               </a:rPr>
-              <a:t>11</a:t>
+              <a:t>12</a:t>
             </a:r>
             <a:endParaRPr lang="en-US" sz="1300" dirty="0"/>
           </a:p>
@@ -9167,24 +9460,24 @@
         </p:nvSpPr>
         <p:spPr>
           <a:xfrm>
-            <a:off x="1207008" y="4974336"/>
-            <a:ext cx="1554480" cy="274320"/>
-          </a:xfrm>
-          <a:prstGeom prst="rect">
-            <a:avLst/>
-          </a:prstGeom>
-          <a:noFill/>
-          <a:ln/>
-        </p:spPr>
-        <p:txBody>
-          <a:bodyPr wrap="square" lIns="0" tIns="0" rIns="0" bIns="0" rtlCol="0" anchor="ctr"/>
-          <a:lstStyle/>
-          <a:p>
-            <a:pPr indent="0" marL="0">
-              <a:buNone/>
-            </a:pPr>
-            <a:r>
-              <a:rPr lang="en-US" sz="1200" b="1" dirty="0">
+            <a:off x="1188720" y="4700016"/>
+            <a:ext cx="2011680" cy="493776"/>
+          </a:xfrm>
+          <a:prstGeom prst="rect">
+            <a:avLst/>
+          </a:prstGeom>
+          <a:noFill/>
+          <a:ln/>
+        </p:spPr>
+        <p:txBody>
+          <a:bodyPr wrap="square" lIns="0" tIns="0" rIns="0" bIns="0" rtlCol="0" anchor="ctr"/>
+          <a:lstStyle/>
+          <a:p>
+            <a:pPr indent="0" marL="0">
+              <a:buNone/>
+            </a:pPr>
+            <a:r>
+              <a:rPr lang="en-US" sz="1150" b="1" dirty="0">
                 <a:solidFill>
                   <a:srgbClr val="22D3EE"/>
                 </a:solidFill>
@@ -9194,7 +9487,7 @@
               </a:rPr>
               <a:t>Voice intent</a:t>
             </a:r>
-            <a:endParaRPr lang="en-US" sz="1200" dirty="0"/>
+            <a:endParaRPr lang="en-US" sz="1150" dirty="0"/>
           </a:p>
         </p:txBody>
       </p:sp>
@@ -9206,24 +9499,63 @@
         </p:nvSpPr>
         <p:spPr>
           <a:xfrm>
-            <a:off x="1207008" y="5230368"/>
-            <a:ext cx="4572000" cy="365760"/>
-          </a:xfrm>
-          <a:prstGeom prst="rect">
-            <a:avLst/>
-          </a:prstGeom>
-          <a:noFill/>
-          <a:ln/>
-        </p:spPr>
-        <p:txBody>
-          <a:bodyPr wrap="square" lIns="0" tIns="0" rIns="0" bIns="0" rtlCol="0" anchor="ctr"/>
-          <a:lstStyle/>
-          <a:p>
-            <a:pPr indent="0" marL="0">
-              <a:buNone/>
-            </a:pPr>
-            <a:r>
-              <a:rPr lang="en-US" sz="1050" dirty="0">
+            <a:off x="3236976" y="4700016"/>
+            <a:ext cx="2697480" cy="493776"/>
+          </a:xfrm>
+          <a:prstGeom prst="rect">
+            <a:avLst/>
+          </a:prstGeom>
+          <a:noFill/>
+          <a:ln/>
+        </p:spPr>
+        <p:txBody>
+          <a:bodyPr wrap="square" lIns="0" tIns="0" rIns="0" bIns="0" rtlCol="0" anchor="ctr"/>
+          <a:lstStyle/>
+          <a:p>
+            <a:pPr indent="0" marL="0">
+              <a:buNone/>
+            </a:pPr>
+            <a:r>
+              <a:rPr lang="en-US" sz="1000" dirty="0">
+                <a:solidFill>
+                  <a:srgbClr val="F8FAFC"/>
+                </a:solidFill>
+                <a:latin typeface="Calibri" pitchFamily="34" charset="0"/>
+                <a:ea typeface="Calibri" pitchFamily="34" charset="-122"/>
+                <a:cs typeface="Calibri" pitchFamily="34" charset="-120"/>
+              </a:rPr>
+              <a:t>Maps a spoken command to a typed application action</a:t>
+            </a:r>
+            <a:endParaRPr lang="en-US" sz="1000" dirty="0"/>
+          </a:p>
+        </p:txBody>
+      </p:sp>
+      <p:sp>
+        <p:nvSpPr>
+          <p:cNvPr id="46" name="Text 44"/>
+          <p:cNvSpPr/>
+          <p:nvPr/>
+        </p:nvSpPr>
+        <p:spPr>
+          <a:xfrm>
+            <a:off x="6236208" y="4700016"/>
+            <a:ext cx="2423160" cy="493776"/>
+          </a:xfrm>
+          <a:prstGeom prst="rect">
+            <a:avLst/>
+          </a:prstGeom>
+          <a:noFill/>
+          <a:ln/>
+        </p:spPr>
+        <p:txBody>
+          <a:bodyPr wrap="square" lIns="0" tIns="0" rIns="0" bIns="0" rtlCol="0" anchor="ctr"/>
+          <a:lstStyle/>
+          <a:p>
+            <a:pPr indent="0" marL="0">
+              <a:buNone/>
+            </a:pPr>
+            <a:r>
+              <a:rPr lang="en-US" sz="950" dirty="0">
                 <a:solidFill>
                   <a:srgbClr val="CADCFC"/>
                 </a:solidFill>
@@ -9231,26 +9563,221 @@
                 <a:ea typeface="Calibri" pitchFamily="34" charset="-122"/>
                 <a:cs typeface="Calibri" pitchFamily="34" charset="-120"/>
               </a:rPr>
-              <a:t>Maps a spoken command to a typed application action — or returns unknown rather than guessing at low confidence.</a:t>
-            </a:r>
-            <a:endParaRPr lang="en-US" sz="1050" dirty="0"/>
-          </a:p>
-        </p:txBody>
-      </p:sp>
-      <p:sp>
-        <p:nvSpPr>
-          <p:cNvPr id="46" name="Shape 44"/>
-          <p:cNvSpPr/>
-          <p:nvPr/>
-        </p:nvSpPr>
-        <p:spPr>
-          <a:xfrm>
-            <a:off x="6181344" y="4846320"/>
-            <a:ext cx="5443423" cy="786384"/>
+              <a:t>Transcribed text plus workspace context</a:t>
+            </a:r>
+            <a:endParaRPr lang="en-US" sz="950" dirty="0"/>
+          </a:p>
+        </p:txBody>
+      </p:sp>
+      <p:sp>
+        <p:nvSpPr>
+          <p:cNvPr id="47" name="Text 45"/>
+          <p:cNvSpPr/>
+          <p:nvPr/>
+        </p:nvSpPr>
+        <p:spPr>
+          <a:xfrm>
+            <a:off x="8961120" y="4700016"/>
+            <a:ext cx="2468880" cy="493776"/>
+          </a:xfrm>
+          <a:prstGeom prst="rect">
+            <a:avLst/>
+          </a:prstGeom>
+          <a:noFill/>
+          <a:ln/>
+        </p:spPr>
+        <p:txBody>
+          <a:bodyPr wrap="square" lIns="0" tIns="0" rIns="0" bIns="0" rtlCol="0" anchor="ctr"/>
+          <a:lstStyle/>
+          <a:p>
+            <a:pPr indent="0" marL="0">
+              <a:buNone/>
+            </a:pPr>
+            <a:r>
+              <a:rPr lang="en-US" sz="950" i="1" dirty="0">
+                <a:solidFill>
+                  <a:srgbClr val="94A3B8"/>
+                </a:solidFill>
+                <a:latin typeface="Calibri" pitchFamily="34" charset="0"/>
+                <a:ea typeface="Calibri" pitchFamily="34" charset="-122"/>
+                <a:cs typeface="Calibri" pitchFamily="34" charset="-120"/>
+              </a:rPr>
+              <a:t>Returns unknown rather than guessing at low confidence</a:t>
+            </a:r>
+            <a:endParaRPr lang="en-US" sz="950" dirty="0"/>
+          </a:p>
+        </p:txBody>
+      </p:sp>
+      <p:sp>
+        <p:nvSpPr>
+          <p:cNvPr id="48" name="Text 46"/>
+          <p:cNvSpPr/>
+          <p:nvPr/>
+        </p:nvSpPr>
+        <p:spPr>
+          <a:xfrm>
+            <a:off x="1188720" y="1133856"/>
+            <a:ext cx="2011680" cy="219456"/>
+          </a:xfrm>
+          <a:prstGeom prst="rect">
+            <a:avLst/>
+          </a:prstGeom>
+          <a:noFill/>
+          <a:ln/>
+        </p:spPr>
+        <p:txBody>
+          <a:bodyPr wrap="square" lIns="0" tIns="0" rIns="0" bIns="0" rtlCol="0" anchor="ctr"/>
+          <a:lstStyle/>
+          <a:p>
+            <a:pPr indent="0" marL="0">
+              <a:buNone/>
+            </a:pPr>
+            <a:r>
+              <a:rPr lang="en-US" sz="900" b="1" spc="120" kern="0" dirty="0">
+                <a:solidFill>
+                  <a:srgbClr val="94A3B8"/>
+                </a:solidFill>
+                <a:latin typeface="Calibri" pitchFamily="34" charset="0"/>
+                <a:ea typeface="Calibri" pitchFamily="34" charset="-122"/>
+                <a:cs typeface="Calibri" pitchFamily="34" charset="-120"/>
+              </a:rPr>
+              <a:t>Capability</a:t>
+            </a:r>
+            <a:endParaRPr lang="en-US" sz="900" dirty="0"/>
+          </a:p>
+        </p:txBody>
+      </p:sp>
+      <p:sp>
+        <p:nvSpPr>
+          <p:cNvPr id="49" name="Text 47"/>
+          <p:cNvSpPr/>
+          <p:nvPr/>
+        </p:nvSpPr>
+        <p:spPr>
+          <a:xfrm>
+            <a:off x="3236976" y="1133856"/>
+            <a:ext cx="2697480" cy="219456"/>
+          </a:xfrm>
+          <a:prstGeom prst="rect">
+            <a:avLst/>
+          </a:prstGeom>
+          <a:noFill/>
+          <a:ln/>
+        </p:spPr>
+        <p:txBody>
+          <a:bodyPr wrap="square" lIns="0" tIns="0" rIns="0" bIns="0" rtlCol="0" anchor="ctr"/>
+          <a:lstStyle/>
+          <a:p>
+            <a:pPr indent="0" marL="0">
+              <a:buNone/>
+            </a:pPr>
+            <a:r>
+              <a:rPr lang="en-US" sz="900" b="1" spc="120" kern="0" dirty="0">
+                <a:solidFill>
+                  <a:srgbClr val="94A3B8"/>
+                </a:solidFill>
+                <a:latin typeface="Calibri" pitchFamily="34" charset="0"/>
+                <a:ea typeface="Calibri" pitchFamily="34" charset="-122"/>
+                <a:cs typeface="Calibri" pitchFamily="34" charset="-120"/>
+              </a:rPr>
+              <a:t>What it does</a:t>
+            </a:r>
+            <a:endParaRPr lang="en-US" sz="900" dirty="0"/>
+          </a:p>
+        </p:txBody>
+      </p:sp>
+      <p:sp>
+        <p:nvSpPr>
+          <p:cNvPr id="50" name="Text 48"/>
+          <p:cNvSpPr/>
+          <p:nvPr/>
+        </p:nvSpPr>
+        <p:spPr>
+          <a:xfrm>
+            <a:off x="6236208" y="1133856"/>
+            <a:ext cx="2423160" cy="219456"/>
+          </a:xfrm>
+          <a:prstGeom prst="rect">
+            <a:avLst/>
+          </a:prstGeom>
+          <a:noFill/>
+          <a:ln/>
+        </p:spPr>
+        <p:txBody>
+          <a:bodyPr wrap="square" lIns="0" tIns="0" rIns="0" bIns="0" rtlCol="0" anchor="ctr"/>
+          <a:lstStyle/>
+          <a:p>
+            <a:pPr indent="0" marL="0">
+              <a:buNone/>
+            </a:pPr>
+            <a:r>
+              <a:rPr lang="en-US" sz="900" b="1" spc="120" kern="0" dirty="0">
+                <a:solidFill>
+                  <a:srgbClr val="94A3B8"/>
+                </a:solidFill>
+                <a:latin typeface="Calibri" pitchFamily="34" charset="0"/>
+                <a:ea typeface="Calibri" pitchFamily="34" charset="-122"/>
+                <a:cs typeface="Calibri" pitchFamily="34" charset="-120"/>
+              </a:rPr>
+              <a:t>Information it uses</a:t>
+            </a:r>
+            <a:endParaRPr lang="en-US" sz="900" dirty="0"/>
+          </a:p>
+        </p:txBody>
+      </p:sp>
+      <p:sp>
+        <p:nvSpPr>
+          <p:cNvPr id="51" name="Text 49"/>
+          <p:cNvSpPr/>
+          <p:nvPr/>
+        </p:nvSpPr>
+        <p:spPr>
+          <a:xfrm>
+            <a:off x="8961120" y="1133856"/>
+            <a:ext cx="2468880" cy="219456"/>
+          </a:xfrm>
+          <a:prstGeom prst="rect">
+            <a:avLst/>
+          </a:prstGeom>
+          <a:noFill/>
+          <a:ln/>
+        </p:spPr>
+        <p:txBody>
+          <a:bodyPr wrap="square" lIns="0" tIns="0" rIns="0" bIns="0" rtlCol="0" anchor="ctr"/>
+          <a:lstStyle/>
+          <a:p>
+            <a:pPr indent="0" marL="0">
+              <a:buNone/>
+            </a:pPr>
+            <a:r>
+              <a:rPr lang="en-US" sz="900" b="1" spc="120" kern="0" dirty="0">
+                <a:solidFill>
+                  <a:srgbClr val="94A3B8"/>
+                </a:solidFill>
+                <a:latin typeface="Calibri" pitchFamily="34" charset="0"/>
+                <a:ea typeface="Calibri" pitchFamily="34" charset="-122"/>
+                <a:cs typeface="Calibri" pitchFamily="34" charset="-120"/>
+              </a:rPr>
+              <a:t>Limitation / risk</a:t>
+            </a:r>
+            <a:endParaRPr lang="en-US" sz="900" dirty="0"/>
+          </a:p>
+        </p:txBody>
+      </p:sp>
+      <p:sp>
+        <p:nvSpPr>
+          <p:cNvPr id="52" name="Shape 50"/>
+          <p:cNvSpPr/>
+          <p:nvPr/>
+        </p:nvSpPr>
+        <p:spPr>
+          <a:xfrm>
+            <a:off x="566928" y="5431536"/>
+            <a:ext cx="11057839" cy="731520"/>
           </a:xfrm>
           <a:prstGeom prst="roundRect">
             <a:avLst>
-              <a:gd name="adj" fmla="val 11628"/>
+              <a:gd name="adj" fmla="val 12500"/>
             </a:avLst>
           </a:prstGeom>
           <a:solidFill>
@@ -9266,14 +9793,14 @@
       </p:sp>
       <p:sp>
         <p:nvSpPr>
-          <p:cNvPr id="47" name="Text 45"/>
-          <p:cNvSpPr/>
-          <p:nvPr/>
-        </p:nvSpPr>
-        <p:spPr>
-          <a:xfrm>
-            <a:off x="6400800" y="4956048"/>
-            <a:ext cx="5004511" cy="585216"/>
+          <p:cNvPr id="53" name="Text 51"/>
+          <p:cNvSpPr/>
+          <p:nvPr/>
+        </p:nvSpPr>
+        <p:spPr>
+          <a:xfrm>
+            <a:off x="786384" y="5522976"/>
+            <a:ext cx="10618927" cy="566928"/>
           </a:xfrm>
           <a:prstGeom prst="rect">
             <a:avLst/>
@@ -9311,7 +9838,7 @@
                 <a:ea typeface="Calibri" pitchFamily="34" charset="-122"/>
                 <a:cs typeface="Calibri" pitchFamily="34" charset="-120"/>
               </a:rPr>
-              <a:t>Every route receives pre-computed figures, is instructed never to recalculate, and degrades to a deterministic fallback — the platform produces identical financial results with no API key at all.</a:t>
+              <a:t>Every route receives pre-computed figures and is instructed never to recalculate. User text is screened for injection and redacted for personal data; outbound access is restricted to the model provider alone. Remove the API key entirely and the financial results are byte-identical.</a:t>
             </a:r>
             <a:endParaRPr lang="en-US" sz="1050" dirty="0"/>
           </a:p>
@@ -9435,12 +9962,12 @@
         </p:nvSpPr>
         <p:spPr>
           <a:xfrm>
-            <a:off x="566928" y="1316736"/>
-            <a:ext cx="5419192" cy="1005840"/>
+            <a:off x="566928" y="1261872"/>
+            <a:ext cx="5419192" cy="896112"/>
           </a:xfrm>
           <a:prstGeom prst="roundRect">
             <a:avLst>
-              <a:gd name="adj" fmla="val 9091"/>
+              <a:gd name="adj" fmla="val 10204"/>
             </a:avLst>
           </a:prstGeom>
           <a:solidFill>
@@ -9469,7 +9996,7 @@
         </p:nvSpPr>
         <p:spPr>
           <a:xfrm>
-            <a:off x="786384" y="1517904"/>
+            <a:off x="786384" y="1426464"/>
             <a:ext cx="310896" cy="310896"/>
           </a:xfrm>
           <a:prstGeom prst="ellipse">
@@ -9494,7 +10021,7 @@
         </p:nvSpPr>
         <p:spPr>
           <a:xfrm>
-            <a:off x="786384" y="1517904"/>
+            <a:off x="786384" y="1426464"/>
             <a:ext cx="310896" cy="310896"/>
           </a:xfrm>
           <a:prstGeom prst="rect">
@@ -9533,24 +10060,24 @@
         </p:nvSpPr>
         <p:spPr>
           <a:xfrm>
-            <a:off x="1207008" y="1499616"/>
-            <a:ext cx="4559656" cy="274320"/>
-          </a:xfrm>
-          <a:prstGeom prst="rect">
-            <a:avLst/>
-          </a:prstGeom>
-          <a:noFill/>
-          <a:ln/>
-        </p:spPr>
-        <p:txBody>
-          <a:bodyPr wrap="square" lIns="0" tIns="0" rIns="0" bIns="0" rtlCol="0" anchor="ctr"/>
-          <a:lstStyle/>
-          <a:p>
-            <a:pPr indent="0" marL="0">
-              <a:buNone/>
-            </a:pPr>
-            <a:r>
-              <a:rPr lang="en-US" sz="1300" b="1" dirty="0">
+            <a:off x="1207008" y="1408176"/>
+            <a:ext cx="4559656" cy="256032"/>
+          </a:xfrm>
+          <a:prstGeom prst="rect">
+            <a:avLst/>
+          </a:prstGeom>
+          <a:noFill/>
+          <a:ln/>
+        </p:spPr>
+        <p:txBody>
+          <a:bodyPr wrap="square" lIns="0" tIns="0" rIns="0" bIns="0" rtlCol="0" anchor="ctr"/>
+          <a:lstStyle/>
+          <a:p>
+            <a:pPr indent="0" marL="0">
+              <a:buNone/>
+            </a:pPr>
+            <a:r>
+              <a:rPr lang="en-US" sz="1250" b="1" dirty="0">
                 <a:solidFill>
                   <a:srgbClr val="22D3EE"/>
                 </a:solidFill>
@@ -9560,7 +10087,7 @@
               </a:rPr>
               <a:t>Accuracy</a:t>
             </a:r>
-            <a:endParaRPr lang="en-US" sz="1300" dirty="0"/>
+            <a:endParaRPr lang="en-US" sz="1250" dirty="0"/>
           </a:p>
         </p:txBody>
       </p:sp>
@@ -9572,24 +10099,24 @@
         </p:nvSpPr>
         <p:spPr>
           <a:xfrm>
-            <a:off x="804672" y="1810512"/>
-            <a:ext cx="4943704" cy="420624"/>
-          </a:xfrm>
-          <a:prstGeom prst="rect">
-            <a:avLst/>
-          </a:prstGeom>
-          <a:noFill/>
-          <a:ln/>
-        </p:spPr>
-        <p:txBody>
-          <a:bodyPr wrap="square" lIns="0" tIns="0" rIns="0" bIns="0" rtlCol="0" anchor="ctr"/>
-          <a:lstStyle/>
-          <a:p>
-            <a:pPr indent="0" marL="0">
-              <a:buNone/>
-            </a:pPr>
-            <a:r>
-              <a:rPr lang="en-US" sz="1100" dirty="0">
+            <a:off x="804672" y="1700784"/>
+            <a:ext cx="4943704" cy="402336"/>
+          </a:xfrm>
+          <a:prstGeom prst="rect">
+            <a:avLst/>
+          </a:prstGeom>
+          <a:noFill/>
+          <a:ln/>
+        </p:spPr>
+        <p:txBody>
+          <a:bodyPr wrap="square" lIns="0" tIns="0" rIns="0" bIns="0" rtlCol="0" anchor="ctr"/>
+          <a:lstStyle/>
+          <a:p>
+            <a:pPr indent="0" marL="0">
+              <a:buNone/>
+            </a:pPr>
+            <a:r>
+              <a:rPr lang="en-US" sz="1050" dirty="0">
                 <a:solidFill>
                   <a:srgbClr val="CADCFC"/>
                 </a:solidFill>
@@ -9599,7 +10126,7 @@
               </a:rPr>
               <a:t>AI output is not verifiable the way a formula is — so it is excluded from every calculation</a:t>
             </a:r>
-            <a:endParaRPr lang="en-US" sz="1100" dirty="0"/>
+            <a:endParaRPr lang="en-US" sz="1050" dirty="0"/>
           </a:p>
         </p:txBody>
       </p:sp>
@@ -9611,12 +10138,12 @@
         </p:nvSpPr>
         <p:spPr>
           <a:xfrm>
-            <a:off x="6205576" y="1316736"/>
-            <a:ext cx="5419192" cy="1005840"/>
+            <a:off x="6205576" y="1261872"/>
+            <a:ext cx="5419192" cy="896112"/>
           </a:xfrm>
           <a:prstGeom prst="roundRect">
             <a:avLst>
-              <a:gd name="adj" fmla="val 9091"/>
+              <a:gd name="adj" fmla="val 10204"/>
             </a:avLst>
           </a:prstGeom>
           <a:solidFill>
@@ -9645,7 +10172,7 @@
         </p:nvSpPr>
         <p:spPr>
           <a:xfrm>
-            <a:off x="6425032" y="1517904"/>
+            <a:off x="6425032" y="1426464"/>
             <a:ext cx="310896" cy="310896"/>
           </a:xfrm>
           <a:prstGeom prst="ellipse">
@@ -9670,7 +10197,7 @@
         </p:nvSpPr>
         <p:spPr>
           <a:xfrm>
-            <a:off x="6425032" y="1517904"/>
+            <a:off x="6425032" y="1426464"/>
             <a:ext cx="310896" cy="310896"/>
           </a:xfrm>
           <a:prstGeom prst="rect">
@@ -9709,24 +10236,24 @@
         </p:nvSpPr>
         <p:spPr>
           <a:xfrm>
-            <a:off x="6845656" y="1499616"/>
-            <a:ext cx="4559656" cy="274320"/>
-          </a:xfrm>
-          <a:prstGeom prst="rect">
-            <a:avLst/>
-          </a:prstGeom>
-          <a:noFill/>
-          <a:ln/>
-        </p:spPr>
-        <p:txBody>
-          <a:bodyPr wrap="square" lIns="0" tIns="0" rIns="0" bIns="0" rtlCol="0" anchor="ctr"/>
-          <a:lstStyle/>
-          <a:p>
-            <a:pPr indent="0" marL="0">
-              <a:buNone/>
-            </a:pPr>
-            <a:r>
-              <a:rPr lang="en-US" sz="1300" b="1" dirty="0">
+            <a:off x="6845656" y="1408176"/>
+            <a:ext cx="4559656" cy="256032"/>
+          </a:xfrm>
+          <a:prstGeom prst="rect">
+            <a:avLst/>
+          </a:prstGeom>
+          <a:noFill/>
+          <a:ln/>
+        </p:spPr>
+        <p:txBody>
+          <a:bodyPr wrap="square" lIns="0" tIns="0" rIns="0" bIns="0" rtlCol="0" anchor="ctr"/>
+          <a:lstStyle/>
+          <a:p>
+            <a:pPr indent="0" marL="0">
+              <a:buNone/>
+            </a:pPr>
+            <a:r>
+              <a:rPr lang="en-US" sz="1250" b="1" dirty="0">
                 <a:solidFill>
                   <a:srgbClr val="22D3EE"/>
                 </a:solidFill>
@@ -9736,7 +10263,7 @@
               </a:rPr>
               <a:t>Incorrect data</a:t>
             </a:r>
-            <a:endParaRPr lang="en-US" sz="1300" dirty="0"/>
+            <a:endParaRPr lang="en-US" sz="1250" dirty="0"/>
           </a:p>
         </p:txBody>
       </p:sp>
@@ -9748,24 +10275,24 @@
         </p:nvSpPr>
         <p:spPr>
           <a:xfrm>
-            <a:off x="6443320" y="1810512"/>
-            <a:ext cx="4943704" cy="420624"/>
-          </a:xfrm>
-          <a:prstGeom prst="rect">
-            <a:avLst/>
-          </a:prstGeom>
-          <a:noFill/>
-          <a:ln/>
-        </p:spPr>
-        <p:txBody>
-          <a:bodyPr wrap="square" lIns="0" tIns="0" rIns="0" bIns="0" rtlCol="0" anchor="ctr"/>
-          <a:lstStyle/>
-          <a:p>
-            <a:pPr indent="0" marL="0">
-              <a:buNone/>
-            </a:pPr>
-            <a:r>
-              <a:rPr lang="en-US" sz="1100" dirty="0">
+            <a:off x="6443320" y="1700784"/>
+            <a:ext cx="4943704" cy="402336"/>
+          </a:xfrm>
+          <a:prstGeom prst="rect">
+            <a:avLst/>
+          </a:prstGeom>
+          <a:noFill/>
+          <a:ln/>
+        </p:spPr>
+        <p:txBody>
+          <a:bodyPr wrap="square" lIns="0" tIns="0" rIns="0" bIns="0" rtlCol="0" anchor="ctr"/>
+          <a:lstStyle/>
+          <a:p>
+            <a:pPr indent="0" marL="0">
+              <a:buNone/>
+            </a:pPr>
+            <a:r>
+              <a:rPr lang="en-US" sz="1050" dirty="0">
                 <a:solidFill>
                   <a:srgbClr val="CADCFC"/>
                 </a:solidFill>
@@ -9775,7 +10302,7 @@
               </a:rPr>
               <a:t>A confident narrative on a wrong input is worse than none, because fluency reads as authority</a:t>
             </a:r>
-            <a:endParaRPr lang="en-US" sz="1100" dirty="0"/>
+            <a:endParaRPr lang="en-US" sz="1050" dirty="0"/>
           </a:p>
         </p:txBody>
       </p:sp>
@@ -9787,12 +10314,12 @@
         </p:nvSpPr>
         <p:spPr>
           <a:xfrm>
-            <a:off x="566928" y="2450592"/>
-            <a:ext cx="5419192" cy="1005840"/>
+            <a:off x="566928" y="2267712"/>
+            <a:ext cx="5419192" cy="896112"/>
           </a:xfrm>
           <a:prstGeom prst="roundRect">
             <a:avLst>
-              <a:gd name="adj" fmla="val 9091"/>
+              <a:gd name="adj" fmla="val 10204"/>
             </a:avLst>
           </a:prstGeom>
           <a:solidFill>
@@ -9821,7 +10348,7 @@
         </p:nvSpPr>
         <p:spPr>
           <a:xfrm>
-            <a:off x="786384" y="2651760"/>
+            <a:off x="786384" y="2432304"/>
             <a:ext cx="310896" cy="310896"/>
           </a:xfrm>
           <a:prstGeom prst="ellipse">
@@ -9846,7 +10373,7 @@
         </p:nvSpPr>
         <p:spPr>
           <a:xfrm>
-            <a:off x="786384" y="2651760"/>
+            <a:off x="786384" y="2432304"/>
             <a:ext cx="310896" cy="310896"/>
           </a:xfrm>
           <a:prstGeom prst="rect">
@@ -9885,24 +10412,24 @@
         </p:nvSpPr>
         <p:spPr>
           <a:xfrm>
-            <a:off x="1207008" y="2633472"/>
-            <a:ext cx="4559656" cy="274320"/>
-          </a:xfrm>
-          <a:prstGeom prst="rect">
-            <a:avLst/>
-          </a:prstGeom>
-          <a:noFill/>
-          <a:ln/>
-        </p:spPr>
-        <p:txBody>
-          <a:bodyPr wrap="square" lIns="0" tIns="0" rIns="0" bIns="0" rtlCol="0" anchor="ctr"/>
-          <a:lstStyle/>
-          <a:p>
-            <a:pPr indent="0" marL="0">
-              <a:buNone/>
-            </a:pPr>
-            <a:r>
-              <a:rPr lang="en-US" sz="1300" b="1" dirty="0">
+            <a:off x="1207008" y="2414016"/>
+            <a:ext cx="4559656" cy="256032"/>
+          </a:xfrm>
+          <a:prstGeom prst="rect">
+            <a:avLst/>
+          </a:prstGeom>
+          <a:noFill/>
+          <a:ln/>
+        </p:spPr>
+        <p:txBody>
+          <a:bodyPr wrap="square" lIns="0" tIns="0" rIns="0" bIns="0" rtlCol="0" anchor="ctr"/>
+          <a:lstStyle/>
+          <a:p>
+            <a:pPr indent="0" marL="0">
+              <a:buNone/>
+            </a:pPr>
+            <a:r>
+              <a:rPr lang="en-US" sz="1250" b="1" dirty="0">
                 <a:solidFill>
                   <a:srgbClr val="22D3EE"/>
                 </a:solidFill>
@@ -9912,7 +10439,7 @@
               </a:rPr>
               <a:t>Hallucination</a:t>
             </a:r>
-            <a:endParaRPr lang="en-US" sz="1300" dirty="0"/>
+            <a:endParaRPr lang="en-US" sz="1250" dirty="0"/>
           </a:p>
         </p:txBody>
       </p:sp>
@@ -9924,24 +10451,24 @@
         </p:nvSpPr>
         <p:spPr>
           <a:xfrm>
-            <a:off x="804672" y="2944368"/>
-            <a:ext cx="4943704" cy="420624"/>
-          </a:xfrm>
-          <a:prstGeom prst="rect">
-            <a:avLst/>
-          </a:prstGeom>
-          <a:noFill/>
-          <a:ln/>
-        </p:spPr>
-        <p:txBody>
-          <a:bodyPr wrap="square" lIns="0" tIns="0" rIns="0" bIns="0" rtlCol="0" anchor="ctr"/>
-          <a:lstStyle/>
-          <a:p>
-            <a:pPr indent="0" marL="0">
-              <a:buNone/>
-            </a:pPr>
-            <a:r>
-              <a:rPr lang="en-US" sz="1100" dirty="0">
+            <a:off x="804672" y="2706624"/>
+            <a:ext cx="4943704" cy="402336"/>
+          </a:xfrm>
+          <a:prstGeom prst="rect">
+            <a:avLst/>
+          </a:prstGeom>
+          <a:noFill/>
+          <a:ln/>
+        </p:spPr>
+        <p:txBody>
+          <a:bodyPr wrap="square" lIns="0" tIns="0" rIns="0" bIns="0" rtlCol="0" anchor="ctr"/>
+          <a:lstStyle/>
+          <a:p>
+            <a:pPr indent="0" marL="0">
+              <a:buNone/>
+            </a:pPr>
+            <a:r>
+              <a:rPr lang="en-US" sz="1050" dirty="0">
                 <a:solidFill>
                   <a:srgbClr val="CADCFC"/>
                 </a:solidFill>
@@ -9951,7 +10478,7 @@
               </a:rPr>
               <a:t>Only validated output enters prompts; the model is instructed never to compute; user text is delimited against injection</a:t>
             </a:r>
-            <a:endParaRPr lang="en-US" sz="1100" dirty="0"/>
+            <a:endParaRPr lang="en-US" sz="1050" dirty="0"/>
           </a:p>
         </p:txBody>
       </p:sp>
@@ -9963,12 +10490,12 @@
         </p:nvSpPr>
         <p:spPr>
           <a:xfrm>
-            <a:off x="6205576" y="2450592"/>
-            <a:ext cx="5419192" cy="1005840"/>
+            <a:off x="6205576" y="2267712"/>
+            <a:ext cx="5419192" cy="896112"/>
           </a:xfrm>
           <a:prstGeom prst="roundRect">
             <a:avLst>
-              <a:gd name="adj" fmla="val 9091"/>
+              <a:gd name="adj" fmla="val 10204"/>
             </a:avLst>
           </a:prstGeom>
           <a:solidFill>
@@ -9997,7 +10524,7 @@
         </p:nvSpPr>
         <p:spPr>
           <a:xfrm>
-            <a:off x="6425032" y="2651760"/>
+            <a:off x="6425032" y="2432304"/>
             <a:ext cx="310896" cy="310896"/>
           </a:xfrm>
           <a:prstGeom prst="ellipse">
@@ -10022,7 +10549,7 @@
         </p:nvSpPr>
         <p:spPr>
           <a:xfrm>
-            <a:off x="6425032" y="2651760"/>
+            <a:off x="6425032" y="2432304"/>
             <a:ext cx="310896" cy="310896"/>
           </a:xfrm>
           <a:prstGeom prst="rect">
@@ -10061,24 +10588,24 @@
         </p:nvSpPr>
         <p:spPr>
           <a:xfrm>
-            <a:off x="6845656" y="2633472"/>
-            <a:ext cx="4559656" cy="274320"/>
-          </a:xfrm>
-          <a:prstGeom prst="rect">
-            <a:avLst/>
-          </a:prstGeom>
-          <a:noFill/>
-          <a:ln/>
-        </p:spPr>
-        <p:txBody>
-          <a:bodyPr wrap="square" lIns="0" tIns="0" rIns="0" bIns="0" rtlCol="0" anchor="ctr"/>
-          <a:lstStyle/>
-          <a:p>
-            <a:pPr indent="0" marL="0">
-              <a:buNone/>
-            </a:pPr>
-            <a:r>
-              <a:rPr lang="en-US" sz="1300" b="1" dirty="0">
+            <a:off x="6845656" y="2414016"/>
+            <a:ext cx="4559656" cy="256032"/>
+          </a:xfrm>
+          <a:prstGeom prst="rect">
+            <a:avLst/>
+          </a:prstGeom>
+          <a:noFill/>
+          <a:ln/>
+        </p:spPr>
+        <p:txBody>
+          <a:bodyPr wrap="square" lIns="0" tIns="0" rIns="0" bIns="0" rtlCol="0" anchor="ctr"/>
+          <a:lstStyle/>
+          <a:p>
+            <a:pPr indent="0" marL="0">
+              <a:buNone/>
+            </a:pPr>
+            <a:r>
+              <a:rPr lang="en-US" sz="1250" b="1" dirty="0">
                 <a:solidFill>
                   <a:srgbClr val="22D3EE"/>
                 </a:solidFill>
@@ -10088,7 +10615,7 @@
               </a:rPr>
               <a:t>Confidentiality</a:t>
             </a:r>
-            <a:endParaRPr lang="en-US" sz="1300" dirty="0"/>
+            <a:endParaRPr lang="en-US" sz="1250" dirty="0"/>
           </a:p>
         </p:txBody>
       </p:sp>
@@ -10100,24 +10627,24 @@
         </p:nvSpPr>
         <p:spPr>
           <a:xfrm>
-            <a:off x="6443320" y="2944368"/>
-            <a:ext cx="4943704" cy="420624"/>
-          </a:xfrm>
-          <a:prstGeom prst="rect">
-            <a:avLst/>
-          </a:prstGeom>
-          <a:noFill/>
-          <a:ln/>
-        </p:spPr>
-        <p:txBody>
-          <a:bodyPr wrap="square" lIns="0" tIns="0" rIns="0" bIns="0" rtlCol="0" anchor="ctr"/>
-          <a:lstStyle/>
-          <a:p>
-            <a:pPr indent="0" marL="0">
-              <a:buNone/>
-            </a:pPr>
-            <a:r>
-              <a:rPr lang="en-US" sz="1100" dirty="0">
+            <a:off x="6443320" y="2706624"/>
+            <a:ext cx="4943704" cy="402336"/>
+          </a:xfrm>
+          <a:prstGeom prst="rect">
+            <a:avLst/>
+          </a:prstGeom>
+          <a:noFill/>
+          <a:ln/>
+        </p:spPr>
+        <p:txBody>
+          <a:bodyPr wrap="square" lIns="0" tIns="0" rIns="0" bIns="0" rtlCol="0" anchor="ctr"/>
+          <a:lstStyle/>
+          <a:p>
+            <a:pPr indent="0" marL="0">
+              <a:buNone/>
+            </a:pPr>
+            <a:r>
+              <a:rPr lang="en-US" sz="1050" dirty="0">
                 <a:solidFill>
                   <a:srgbClr val="CADCFC"/>
                 </a:solidFill>
@@ -10127,7 +10654,7 @@
               </a:rPr>
               <a:t>No personal or customer data is transmitted; credentials stay server-side in route handlers</a:t>
             </a:r>
-            <a:endParaRPr lang="en-US" sz="1100" dirty="0"/>
+            <a:endParaRPr lang="en-US" sz="1050" dirty="0"/>
           </a:p>
         </p:txBody>
       </p:sp>
@@ -10139,12 +10666,12 @@
         </p:nvSpPr>
         <p:spPr>
           <a:xfrm>
-            <a:off x="566928" y="3584448"/>
-            <a:ext cx="5419192" cy="1005840"/>
+            <a:off x="566928" y="3273552"/>
+            <a:ext cx="5419192" cy="896112"/>
           </a:xfrm>
           <a:prstGeom prst="roundRect">
             <a:avLst>
-              <a:gd name="adj" fmla="val 9091"/>
+              <a:gd name="adj" fmla="val 10204"/>
             </a:avLst>
           </a:prstGeom>
           <a:solidFill>
@@ -10173,7 +10700,7 @@
         </p:nvSpPr>
         <p:spPr>
           <a:xfrm>
-            <a:off x="786384" y="3785616"/>
+            <a:off x="786384" y="3438144"/>
             <a:ext cx="310896" cy="310896"/>
           </a:xfrm>
           <a:prstGeom prst="ellipse">
@@ -10198,7 +10725,7 @@
         </p:nvSpPr>
         <p:spPr>
           <a:xfrm>
-            <a:off x="786384" y="3785616"/>
+            <a:off x="786384" y="3438144"/>
             <a:ext cx="310896" cy="310896"/>
           </a:xfrm>
           <a:prstGeom prst="rect">
@@ -10237,24 +10764,24 @@
         </p:nvSpPr>
         <p:spPr>
           <a:xfrm>
-            <a:off x="1207008" y="3767328"/>
-            <a:ext cx="4559656" cy="274320"/>
-          </a:xfrm>
-          <a:prstGeom prst="rect">
-            <a:avLst/>
-          </a:prstGeom>
-          <a:noFill/>
-          <a:ln/>
-        </p:spPr>
-        <p:txBody>
-          <a:bodyPr wrap="square" lIns="0" tIns="0" rIns="0" bIns="0" rtlCol="0" anchor="ctr"/>
-          <a:lstStyle/>
-          <a:p>
-            <a:pPr indent="0" marL="0">
-              <a:buNone/>
-            </a:pPr>
-            <a:r>
-              <a:rPr lang="en-US" sz="1300" b="1" dirty="0">
+            <a:off x="1207008" y="3419856"/>
+            <a:ext cx="4559656" cy="256032"/>
+          </a:xfrm>
+          <a:prstGeom prst="rect">
+            <a:avLst/>
+          </a:prstGeom>
+          <a:noFill/>
+          <a:ln/>
+        </p:spPr>
+        <p:txBody>
+          <a:bodyPr wrap="square" lIns="0" tIns="0" rIns="0" bIns="0" rtlCol="0" anchor="ctr"/>
+          <a:lstStyle/>
+          <a:p>
+            <a:pPr indent="0" marL="0">
+              <a:buNone/>
+            </a:pPr>
+            <a:r>
+              <a:rPr lang="en-US" sz="1250" b="1" dirty="0">
                 <a:solidFill>
                   <a:srgbClr val="22D3EE"/>
                 </a:solidFill>
@@ -10264,7 +10791,7 @@
               </a:rPr>
               <a:t>Bias</a:t>
             </a:r>
-            <a:endParaRPr lang="en-US" sz="1300" dirty="0"/>
+            <a:endParaRPr lang="en-US" sz="1250" dirty="0"/>
           </a:p>
         </p:txBody>
       </p:sp>
@@ -10276,24 +10803,24 @@
         </p:nvSpPr>
         <p:spPr>
           <a:xfrm>
-            <a:off x="804672" y="4078224"/>
-            <a:ext cx="4943704" cy="420624"/>
-          </a:xfrm>
-          <a:prstGeom prst="rect">
-            <a:avLst/>
-          </a:prstGeom>
-          <a:noFill/>
-          <a:ln/>
-        </p:spPr>
-        <p:txBody>
-          <a:bodyPr wrap="square" lIns="0" tIns="0" rIns="0" bIns="0" rtlCol="0" anchor="ctr"/>
-          <a:lstStyle/>
-          <a:p>
-            <a:pPr indent="0" marL="0">
-              <a:buNone/>
-            </a:pPr>
-            <a:r>
-              <a:rPr lang="en-US" sz="1100" dirty="0">
+            <a:off x="804672" y="3712464"/>
+            <a:ext cx="4943704" cy="402336"/>
+          </a:xfrm>
+          <a:prstGeom prst="rect">
+            <a:avLst/>
+          </a:prstGeom>
+          <a:noFill/>
+          <a:ln/>
+        </p:spPr>
+        <p:txBody>
+          <a:bodyPr wrap="square" lIns="0" tIns="0" rIns="0" bIns="0" rtlCol="0" anchor="ctr"/>
+          <a:lstStyle/>
+          <a:p>
+            <a:pPr indent="0" marL="0">
+              <a:buNone/>
+            </a:pPr>
+            <a:r>
+              <a:rPr lang="en-US" sz="1050" dirty="0">
                 <a:solidFill>
                   <a:srgbClr val="CADCFC"/>
                 </a:solidFill>
@@ -10303,7 +10830,7 @@
               </a:rPr>
               <a:t>Forecasts inherit the optimism of whoever set them — the pessimistic case, risk panel and board debate are counterweights</a:t>
             </a:r>
-            <a:endParaRPr lang="en-US" sz="1100" dirty="0"/>
+            <a:endParaRPr lang="en-US" sz="1050" dirty="0"/>
           </a:p>
         </p:txBody>
       </p:sp>
@@ -10315,12 +10842,12 @@
         </p:nvSpPr>
         <p:spPr>
           <a:xfrm>
-            <a:off x="6205576" y="3584448"/>
-            <a:ext cx="5419192" cy="1005840"/>
+            <a:off x="6205576" y="3273552"/>
+            <a:ext cx="5419192" cy="896112"/>
           </a:xfrm>
           <a:prstGeom prst="roundRect">
             <a:avLst>
-              <a:gd name="adj" fmla="val 9091"/>
+              <a:gd name="adj" fmla="val 10204"/>
             </a:avLst>
           </a:prstGeom>
           <a:solidFill>
@@ -10349,7 +10876,7 @@
         </p:nvSpPr>
         <p:spPr>
           <a:xfrm>
-            <a:off x="6425032" y="3785616"/>
+            <a:off x="6425032" y="3438144"/>
             <a:ext cx="310896" cy="310896"/>
           </a:xfrm>
           <a:prstGeom prst="ellipse">
@@ -10374,7 +10901,7 @@
         </p:nvSpPr>
         <p:spPr>
           <a:xfrm>
-            <a:off x="6425032" y="3785616"/>
+            <a:off x="6425032" y="3438144"/>
             <a:ext cx="310896" cy="310896"/>
           </a:xfrm>
           <a:prstGeom prst="rect">
@@ -10413,24 +10940,24 @@
         </p:nvSpPr>
         <p:spPr>
           <a:xfrm>
-            <a:off x="6845656" y="3767328"/>
-            <a:ext cx="4559656" cy="274320"/>
-          </a:xfrm>
-          <a:prstGeom prst="rect">
-            <a:avLst/>
-          </a:prstGeom>
-          <a:noFill/>
-          <a:ln/>
-        </p:spPr>
-        <p:txBody>
-          <a:bodyPr wrap="square" lIns="0" tIns="0" rIns="0" bIns="0" rtlCol="0" anchor="ctr"/>
-          <a:lstStyle/>
-          <a:p>
-            <a:pPr indent="0" marL="0">
-              <a:buNone/>
-            </a:pPr>
-            <a:r>
-              <a:rPr lang="en-US" sz="1300" b="1" dirty="0">
+            <a:off x="6845656" y="3419856"/>
+            <a:ext cx="4559656" cy="256032"/>
+          </a:xfrm>
+          <a:prstGeom prst="rect">
+            <a:avLst/>
+          </a:prstGeom>
+          <a:noFill/>
+          <a:ln/>
+        </p:spPr>
+        <p:txBody>
+          <a:bodyPr wrap="square" lIns="0" tIns="0" rIns="0" bIns="0" rtlCol="0" anchor="ctr"/>
+          <a:lstStyle/>
+          <a:p>
+            <a:pPr indent="0" marL="0">
+              <a:buNone/>
+            </a:pPr>
+            <a:r>
+              <a:rPr lang="en-US" sz="1250" b="1" dirty="0">
                 <a:solidFill>
                   <a:srgbClr val="22D3EE"/>
                 </a:solidFill>
@@ -10440,7 +10967,7 @@
               </a:rPr>
               <a:t>Human review</a:t>
             </a:r>
-            <a:endParaRPr lang="en-US" sz="1300" dirty="0"/>
+            <a:endParaRPr lang="en-US" sz="1250" dirty="0"/>
           </a:p>
         </p:txBody>
       </p:sp>
@@ -10452,24 +10979,24 @@
         </p:nvSpPr>
         <p:spPr>
           <a:xfrm>
-            <a:off x="6443320" y="4078224"/>
-            <a:ext cx="4943704" cy="420624"/>
-          </a:xfrm>
-          <a:prstGeom prst="rect">
-            <a:avLst/>
-          </a:prstGeom>
-          <a:noFill/>
-          <a:ln/>
-        </p:spPr>
-        <p:txBody>
-          <a:bodyPr wrap="square" lIns="0" tIns="0" rIns="0" bIns="0" rtlCol="0" anchor="ctr"/>
-          <a:lstStyle/>
-          <a:p>
-            <a:pPr indent="0" marL="0">
-              <a:buNone/>
-            </a:pPr>
-            <a:r>
-              <a:rPr lang="en-US" sz="1100" dirty="0">
+            <a:off x="6443320" y="3712464"/>
+            <a:ext cx="4943704" cy="402336"/>
+          </a:xfrm>
+          <a:prstGeom prst="rect">
+            <a:avLst/>
+          </a:prstGeom>
+          <a:noFill/>
+          <a:ln/>
+        </p:spPr>
+        <p:txBody>
+          <a:bodyPr wrap="square" lIns="0" tIns="0" rIns="0" bIns="0" rtlCol="0" anchor="ctr"/>
+          <a:lstStyle/>
+          <a:p>
+            <a:pPr indent="0" marL="0">
+              <a:buNone/>
+            </a:pPr>
+            <a:r>
+              <a:rPr lang="en-US" sz="1050" dirty="0">
                 <a:solidFill>
                   <a:srgbClr val="CADCFC"/>
                 </a:solidFill>
@@ -10479,7 +11006,7 @@
               </a:rPr>
               <a:t>Every response is labelled advisory, carries a provenance badge, and requires sign-off</a:t>
             </a:r>
-            <a:endParaRPr lang="en-US" sz="1100" dirty="0"/>
+            <a:endParaRPr lang="en-US" sz="1050" dirty="0"/>
           </a:p>
         </p:txBody>
       </p:sp>
@@ -10491,12 +11018,92 @@
         </p:nvSpPr>
         <p:spPr>
           <a:xfrm>
-            <a:off x="566928" y="4828032"/>
-            <a:ext cx="11057839" cy="841248"/>
+            <a:off x="566928" y="4315968"/>
+            <a:ext cx="11057839" cy="914400"/>
           </a:xfrm>
           <a:prstGeom prst="roundRect">
             <a:avLst>
-              <a:gd name="adj" fmla="val 10870"/>
+              <a:gd name="adj" fmla="val 10000"/>
+            </a:avLst>
+          </a:prstGeom>
+          <a:solidFill>
+            <a:srgbClr val="3B2E0C"/>
+          </a:solidFill>
+          <a:ln w="19050">
+            <a:solidFill>
+              <a:srgbClr val="FBBF24"/>
+            </a:solidFill>
+            <a:prstDash val="solid"/>
+          </a:ln>
+        </p:spPr>
+      </p:sp>
+      <p:sp>
+        <p:nvSpPr>
+          <p:cNvPr id="35" name="Text 33"/>
+          <p:cNvSpPr/>
+          <p:nvPr/>
+        </p:nvSpPr>
+        <p:spPr>
+          <a:xfrm>
+            <a:off x="841248" y="4407408"/>
+            <a:ext cx="10509199" cy="731520"/>
+          </a:xfrm>
+          <a:prstGeom prst="rect">
+            <a:avLst/>
+          </a:prstGeom>
+          <a:noFill/>
+          <a:ln/>
+        </p:spPr>
+        <p:txBody>
+          <a:bodyPr wrap="square" lIns="0" tIns="0" rIns="0" bIns="0" rtlCol="0" anchor="ctr"/>
+          <a:lstStyle/>
+          <a:p>
+            <a:pPr indent="0" marL="0">
+              <a:buNone/>
+            </a:pPr>
+            <a:r>
+              <a:rPr lang="en-US" sz="1150" b="1" dirty="0">
+                <a:solidFill>
+                  <a:srgbClr val="FBBF24"/>
+                </a:solidFill>
+                <a:latin typeface="Calibri" pitchFamily="34" charset="0"/>
+                <a:ea typeface="Calibri" pitchFamily="34" charset="-122"/>
+                <a:cs typeface="Calibri" pitchFamily="34" charset="-120"/>
+              </a:rPr>
+              <a:t>We found one of these in our own build.  </a:t>
+            </a:r>
+            <a:pPr indent="0" marL="0">
+              <a:buNone/>
+            </a:pPr>
+            <a:r>
+              <a:rPr lang="en-US" sz="1150" dirty="0">
+                <a:solidFill>
+                  <a:srgbClr val="CADCFC"/>
+                </a:solidFill>
+                <a:latin typeface="Calibri" pitchFamily="34" charset="0"/>
+                <a:ea typeface="Calibri" pitchFamily="34" charset="-122"/>
+                <a:cs typeface="Calibri" pitchFamily="34" charset="-120"/>
+              </a:rPr>
+              <a:t>The macro panel once prompted the model as a real-time data ingestion agent and published the output as observed market data. Nothing was ever fetched — every rate, tariff and lease price shown to the committee had been generated. It now serves hand-transcribed values with citations, flagged not live.</a:t>
+            </a:r>
+            <a:endParaRPr lang="en-US" sz="1150" dirty="0"/>
+          </a:p>
+        </p:txBody>
+      </p:sp>
+      <p:sp>
+        <p:nvSpPr>
+          <p:cNvPr id="36" name="Shape 34"/>
+          <p:cNvSpPr/>
+          <p:nvPr/>
+        </p:nvSpPr>
+        <p:spPr>
+          <a:xfrm>
+            <a:off x="566928" y="5358384"/>
+            <a:ext cx="11057839" cy="749808"/>
+          </a:xfrm>
+          <a:prstGeom prst="roundRect">
+            <a:avLst>
+              <a:gd name="adj" fmla="val 12195"/>
             </a:avLst>
           </a:prstGeom>
           <a:solidFill>
@@ -10512,30 +11119,30 @@
       </p:sp>
       <p:sp>
         <p:nvSpPr>
-          <p:cNvPr id="35" name="Text 33"/>
-          <p:cNvSpPr/>
-          <p:nvPr/>
-        </p:nvSpPr>
-        <p:spPr>
-          <a:xfrm>
-            <a:off x="877824" y="4956048"/>
-            <a:ext cx="10436047" cy="585216"/>
-          </a:xfrm>
-          <a:prstGeom prst="rect">
-            <a:avLst/>
-          </a:prstGeom>
-          <a:noFill/>
-          <a:ln/>
-        </p:spPr>
-        <p:txBody>
-          <a:bodyPr wrap="square" lIns="0" tIns="0" rIns="0" bIns="0" rtlCol="0" anchor="ctr"/>
-          <a:lstStyle/>
-          <a:p>
-            <a:pPr indent="0" marL="0">
-              <a:buNone/>
-            </a:pPr>
-            <a:r>
-              <a:rPr lang="en-US" sz="1300" b="1" dirty="0">
+          <p:cNvPr id="37" name="Text 35"/>
+          <p:cNvSpPr/>
+          <p:nvPr/>
+        </p:nvSpPr>
+        <p:spPr>
+          <a:xfrm>
+            <a:off x="877824" y="5449824"/>
+            <a:ext cx="10436047" cy="566928"/>
+          </a:xfrm>
+          <a:prstGeom prst="rect">
+            <a:avLst/>
+          </a:prstGeom>
+          <a:noFill/>
+          <a:ln/>
+        </p:spPr>
+        <p:txBody>
+          <a:bodyPr wrap="square" lIns="0" tIns="0" rIns="0" bIns="0" rtlCol="0" anchor="ctr"/>
+          <a:lstStyle/>
+          <a:p>
+            <a:pPr indent="0" marL="0">
+              <a:buNone/>
+            </a:pPr>
+            <a:r>
+              <a:rPr lang="en-US" sz="1250" b="1" dirty="0">
                 <a:solidFill>
                   <a:srgbClr val="22D3EE"/>
                 </a:solidFill>
@@ -10549,7 +11156,7 @@
               <a:buNone/>
             </a:pPr>
             <a:r>
-              <a:rPr lang="en-US" sz="1300" dirty="0">
+              <a:rPr lang="en-US" sz="1250" dirty="0">
                 <a:solidFill>
                   <a:srgbClr val="F8FAFC"/>
                 </a:solidFill>
@@ -10559,7 +11166,7 @@
               </a:rPr>
               <a:t>Final responsibility for this investment decision rests with the Chief Financial Officer and the Capital Expenditure Committee. It does not rest with the AI system, and no output here should be read as transferring it.</a:t>
             </a:r>
-            <a:endParaRPr lang="en-US" sz="1300" dirty="0"/>
+            <a:endParaRPr lang="en-US" sz="1250" dirty="0"/>
           </a:p>
         </p:txBody>
       </p:sp>

</xml_diff>

<commit_message>
feat: wire real AI advisory, add Tier 1 decision-intelligence features, fix E2E auth, close brief gaps
</commit_message>
<xml_diff>
--- a/submissions/CapExIQ_Executive_Presentation.pptx
+++ b/submissions/CapExIQ_Executive_Presentation.pptx
@@ -1742,7 +1742,7 @@
           <a:p>
             <a:r>
               <a:rPr lang="en-US" dirty="0"/>
-              <a:t>Question four. Twelve capabilities, each documented against the five points the brief asks for. Start at the top: the assistant now retrieves the relevant documentation before it answers, so every claim carries a numbered citation you can expand to the source extract. That turns an unverifiable answer into a checkable one. The limitation column on the right is the one I care about. The board recommendation will write a perfectly confident memorandum from bad inputs, which is why sign-off is mandatory. And board debate manufactures the challenge a single author cannot supply — but simulated dissent is not real governance, and I would not claim otherwise. (40s)</a:t>
+              <a:t>Question four. Sixteen capabilities, each documented against the five points the brief asks for. Start at the top: the assistant now retrieves the relevant documentation before it answers, so every claim carries a numbered citation you can expand to the source extract. That turns an unverifiable answer into a checkable one. The limitation column on the right is the one I care about. The board recommendation will write a perfectly confident memorandum from bad inputs, which is why sign-off is mandatory. And board debate manufactures the challenge a single author cannot supply — but simulated dissent is not real governance, and I would not claim otherwise. (40s)</a:t>
             </a:r>
             <a:endParaRPr lang="en-US" dirty="0"/>
           </a:p>
@@ -3850,7 +3850,7 @@
                 <a:ea typeface="Calibri" pitchFamily="34" charset="-122"/>
                 <a:cs typeface="Calibri" pitchFamily="34" charset="-120"/>
               </a:rPr>
-              <a:t>Deterministic finance engine  ·  12 AI capabilities  ·  8 investment archetypes  ·  Role-based access control</a:t>
+              <a:t>Deterministic finance engine  ·  16 AI capabilities  ·  8 investment archetypes  ·  Role-based access control</a:t>
             </a:r>
             <a:endParaRPr lang="en-US" sz="1100" dirty="0"/>
           </a:p>
@@ -6156,7 +6156,7 @@
                 <a:ea typeface="Cambria" pitchFamily="34" charset="-122"/>
                 <a:cs typeface="Cambria" pitchFamily="34" charset="-120"/>
               </a:rPr>
-              <a:t>Twelve AI capabilities — the first six</a:t>
+              <a:t>Sixteen AI capabilities — decision core</a:t>
             </a:r>
             <a:endParaRPr lang="en-US" sz="3000" dirty="0"/>
           </a:p>
@@ -6437,7 +6437,7 @@
                 <a:ea typeface="Calibri" pitchFamily="34" charset="-122"/>
                 <a:cs typeface="Calibri" pitchFamily="34" charset="-120"/>
               </a:rPr>
-              <a:t>A 112-passage corpus built from the methodology and assumption register</a:t>
+              <a:t>A 90-passage corpus built from the methodology and assumption register</a:t>
             </a:r>
             <a:endParaRPr lang="en-US" sz="950" dirty="0"/>
           </a:p>
@@ -8012,7 +8012,7 @@
                 <a:ea typeface="Cambria" pitchFamily="34" charset="-122"/>
                 <a:cs typeface="Cambria" pitchFamily="34" charset="-120"/>
               </a:rPr>
-              <a:t>Twelve AI capabilities — the second six</a:t>
+              <a:t>Sixteen AI capabilities — advisory and governance</a:t>
             </a:r>
             <a:endParaRPr lang="en-US" sz="3000" dirty="0"/>
           </a:p>
@@ -9231,7 +9231,7 @@
                 <a:ea typeface="Calibri" pitchFamily="34" charset="-122"/>
                 <a:cs typeface="Calibri" pitchFamily="34" charset="-120"/>
               </a:rPr>
-              <a:t>Macro reference</a:t>
+              <a:t>Driver attribution</a:t>
             </a:r>
             <a:endParaRPr lang="en-US" sz="1150" dirty="0"/>
           </a:p>
@@ -9270,7 +9270,7 @@
                 <a:ea typeface="Calibri" pitchFamily="34" charset="-122"/>
                 <a:cs typeface="Calibri" pitchFamily="34" charset="-120"/>
               </a:rPr>
-              <a:t>Presents the external rate, tariff and tax basis behind the model</a:t>
+              <a:t>Decomposes an NPV movement into each assumption’s contribution</a:t>
             </a:r>
             <a:endParaRPr lang="en-US" sz="1000" dirty="0"/>
           </a:p>
@@ -9309,7 +9309,7 @@
                 <a:ea typeface="Calibri" pitchFamily="34" charset="-122"/>
                 <a:cs typeface="Calibri" pitchFamily="34" charset="-120"/>
               </a:rPr>
-              <a:t>Values transcribed by hand, each with citation and as-of date</a:t>
+              <a:t>Two assumption sets and the engine output for each</a:t>
             </a:r>
             <a:endParaRPr lang="en-US" sz="950" dirty="0"/>
           </a:p>
@@ -9348,7 +9348,7 @@
                 <a:ea typeface="Calibri" pitchFamily="34" charset="-122"/>
                 <a:cs typeface="Calibri" pitchFamily="34" charset="-120"/>
               </a:rPr>
-              <a:t>Point-in-time — flagged not live, and re-transcribed as sources change</a:t>
+              <a:t>Attributed shares depend on a fixed, documented substitution order</a:t>
             </a:r>
             <a:endParaRPr lang="en-US" sz="950" dirty="0"/>
           </a:p>

</xml_diff>